<commit_message>
Add dark chapter-card covers + 6-session course overview page
- Rebuild all 6 covers into the approved dark chapter-card layout: cream
  canvas, dark-navy card with large session numeral + SESSION label + EN
  kicker, gothic ink headline, orange tick, sub-line, bullet list
- Insert a "6강 커리큘럼" course-overview page as slide 2 of S1: 3×2 grid
  of all six sessions (S1 featured in dark navy), gothic type, orange spark
  accents — a single roadmap page introducing the whole series

Co-Authored-By: Claude Opus 4.8 <noreply@anthropic.com>
Claude-Session: https://claude.ai/code/session_011RDDnHGRi5mzhXv4yoo5bY
</commit_message>
<xml_diff>
--- a/S1_claude-style.pptx
+++ b/S1_claude-style.pptx
@@ -6,6 +6,7 @@
   </p:sldMasterIdLst>
   <p:sldIdLst>
     <p:sldId id="256" r:id="rId7"/>
+    <p:sldId id="294" r:id="rId45"/>
     <p:sldId id="257" r:id="rId8"/>
     <p:sldId id="258" r:id="rId9"/>
     <p:sldId id="259" r:id="rId10"/>
@@ -3479,10 +3480,56 @@
         <p:spPr>
           <a:xfrm>
             <a:off x="0" y="0"/>
-            <a:ext cx="256032" cy="6858000"/>
-          </a:xfrm>
-          <a:prstGeom prst="rect">
-            <a:avLst/>
+            <a:ext cx="12191695" cy="6858000"/>
+          </a:xfrm>
+          <a:prstGeom prst="rect">
+            <a:avLst/>
+          </a:prstGeom>
+          <a:solidFill>
+            <a:srgbClr val="FAF9F5"/>
+          </a:solidFill>
+          <a:ln>
+            <a:noFill/>
+          </a:ln>
+          <a:effectLst/>
+        </p:spPr>
+        <p:style>
+          <a:lnRef idx="1">
+            <a:schemeClr val="accent1"/>
+          </a:lnRef>
+          <a:fillRef idx="3">
+            <a:schemeClr val="accent1"/>
+          </a:fillRef>
+          <a:effectRef idx="2">
+            <a:schemeClr val="accent1"/>
+          </a:effectRef>
+          <a:fontRef idx="minor">
+            <a:schemeClr val="lt1"/>
+          </a:fontRef>
+        </p:style>
+        <p:txBody>
+          <a:bodyPr rtlCol="0" anchor="ctr"/>
+          <a:lstStyle/>
+          <a:p>
+            <a:pPr algn="ctr"/>
+          </a:p>
+        </p:txBody>
+      </p:sp>
+      <p:sp>
+        <p:nvSpPr>
+          <p:cNvPr id="3" name="Rounded Rectangle 2"/>
+          <p:cNvSpPr/>
+          <p:nvPr/>
+        </p:nvSpPr>
+        <p:spPr>
+          <a:xfrm>
+            <a:off x="658368" y="548640"/>
+            <a:ext cx="118872" cy="118872"/>
+          </a:xfrm>
+          <a:prstGeom prst="roundRect">
+            <a:avLst>
+              <a:gd name="adj" fmla="val 25000"/>
+            </a:avLst>
           </a:prstGeom>
           <a:solidFill>
             <a:srgbClr val="F37021"/>
@@ -3516,39 +3563,70 @@
       </p:sp>
       <p:sp>
         <p:nvSpPr>
-          <p:cNvPr id="3" name="TextBox 2"/>
-          <p:cNvSpPr txBox="1"/>
-          <p:nvPr/>
-        </p:nvSpPr>
-        <p:spPr>
-          <a:xfrm>
-            <a:off x="868680" y="777240"/>
-            <a:ext cx="9144000" cy="365760"/>
-          </a:xfrm>
-          <a:prstGeom prst="rect">
-            <a:avLst/>
-          </a:prstGeom>
-          <a:noFill/>
-        </p:spPr>
-        <p:txBody>
-          <a:bodyPr wrap="square" lIns="25400" rIns="25400" tIns="12700" bIns="12700" anchor="t">
-            <a:spAutoFit/>
-          </a:bodyPr>
-          <a:lstStyle/>
-          <a:p>
-            <a:pPr algn="l">
-              <a:lnSpc>
-                <a:spcPct val="115000"/>
-              </a:lnSpc>
-            </a:pPr>
-            <a:r>
-              <a:rPr sz="1200" b="1" i="0" spc="350">
-                <a:solidFill>
-                  <a:srgbClr val="8E8B82"/>
-                </a:solidFill>
-                <a:latin typeface="맑은 고딕"/>
-                <a:ea typeface="맑은 고딕"/>
-                <a:cs typeface="맑은 고딕"/>
+          <p:cNvPr id="4" name="TextBox 3"/>
+          <p:cNvSpPr txBox="1"/>
+          <p:nvPr/>
+        </p:nvSpPr>
+        <p:spPr>
+          <a:xfrm>
+            <a:off x="868680" y="502920"/>
+            <a:ext cx="6400800" cy="274320"/>
+          </a:xfrm>
+          <a:prstGeom prst="rect">
+            <a:avLst/>
+          </a:prstGeom>
+          <a:noFill/>
+        </p:spPr>
+        <p:txBody>
+          <a:bodyPr wrap="square" anchor="t" lIns="0" rIns="0" tIns="0" bIns="0">
+            <a:spAutoFit/>
+          </a:bodyPr>
+          <a:lstStyle/>
+          <a:p>
+            <a:pPr algn="l"/>
+            <a:r>
+              <a:rPr sz="1100" b="0" spc="150">
+                <a:solidFill>
+                  <a:srgbClr val="6C6A64"/>
+                </a:solidFill>
+                <a:latin typeface="맑은 고딕"/>
+                <a:ea typeface="맑은 고딕"/>
+              </a:rPr>
+              <a:t>AI 검색 시대 마케팅 — SEO·AEO·GEO 6강 완성 과정</a:t>
+            </a:r>
+          </a:p>
+        </p:txBody>
+      </p:sp>
+      <p:sp>
+        <p:nvSpPr>
+          <p:cNvPr id="5" name="TextBox 4"/>
+          <p:cNvSpPr txBox="1"/>
+          <p:nvPr/>
+        </p:nvSpPr>
+        <p:spPr>
+          <a:xfrm>
+            <a:off x="6400800" y="502920"/>
+            <a:ext cx="5148072" cy="274320"/>
+          </a:xfrm>
+          <a:prstGeom prst="rect">
+            <a:avLst/>
+          </a:prstGeom>
+          <a:noFill/>
+        </p:spPr>
+        <p:txBody>
+          <a:bodyPr wrap="square" anchor="t" lIns="0" rIns="0" tIns="0" bIns="0">
+            <a:spAutoFit/>
+          </a:bodyPr>
+          <a:lstStyle/>
+          <a:p>
+            <a:pPr algn="r"/>
+            <a:r>
+              <a:rPr sz="1100" b="0" spc="150">
+                <a:solidFill>
+                  <a:srgbClr val="6C6A64"/>
+                </a:solidFill>
+                <a:latin typeface="맑은 고딕"/>
+                <a:ea typeface="맑은 고딕"/>
               </a:rPr>
               <a:t>SESSION 1 / 6</a:t>
             </a:r>
@@ -3557,41 +3635,160 @@
       </p:sp>
       <p:sp>
         <p:nvSpPr>
-          <p:cNvPr id="4" name="TextBox 3"/>
-          <p:cNvSpPr txBox="1"/>
-          <p:nvPr/>
-        </p:nvSpPr>
-        <p:spPr>
-          <a:xfrm>
-            <a:off x="6720840" y="274320"/>
-            <a:ext cx="4937760" cy="2926080"/>
+          <p:cNvPr id="6" name="Rectangle 5"/>
+          <p:cNvSpPr/>
+          <p:nvPr/>
+        </p:nvSpPr>
+        <p:spPr>
+          <a:xfrm>
+            <a:off x="658368" y="841248"/>
+            <a:ext cx="10890504" cy="10972"/>
+          </a:xfrm>
+          <a:prstGeom prst="rect">
+            <a:avLst/>
+          </a:prstGeom>
+          <a:solidFill>
+            <a:srgbClr val="E6DFD8"/>
+          </a:solidFill>
+          <a:ln>
+            <a:noFill/>
+          </a:ln>
+          <a:effectLst/>
+        </p:spPr>
+        <p:style>
+          <a:lnRef idx="1">
+            <a:schemeClr val="accent1"/>
+          </a:lnRef>
+          <a:fillRef idx="3">
+            <a:schemeClr val="accent1"/>
+          </a:fillRef>
+          <a:effectRef idx="2">
+            <a:schemeClr val="accent1"/>
+          </a:effectRef>
+          <a:fontRef idx="minor">
+            <a:schemeClr val="lt1"/>
+          </a:fontRef>
+        </p:style>
+        <p:txBody>
+          <a:bodyPr rtlCol="0" anchor="ctr"/>
+          <a:lstStyle/>
+          <a:p>
+            <a:pPr algn="ctr"/>
+          </a:p>
+        </p:txBody>
+      </p:sp>
+      <p:sp>
+        <p:nvSpPr>
+          <p:cNvPr id="7" name="Rounded Rectangle 6"/>
+          <p:cNvSpPr/>
+          <p:nvPr/>
+        </p:nvSpPr>
+        <p:spPr>
+          <a:xfrm>
+            <a:off x="8183879" y="1371600"/>
+            <a:ext cx="3364992" cy="4114800"/>
           </a:xfrm>
           <a:prstGeom prst="roundRect">
             <a:avLst>
-              <a:gd name="adj" fmla="val 5000"/>
+              <a:gd name="adj" fmla="val 7000"/>
             </a:avLst>
           </a:prstGeom>
-          <a:noFill/>
-        </p:spPr>
-        <p:txBody>
-          <a:bodyPr wrap="square" lIns="25400" rIns="25400" tIns="12700" bIns="12700" anchor="t">
-            <a:spAutoFit/>
-          </a:bodyPr>
-          <a:lstStyle/>
-          <a:p>
-            <a:pPr algn="r">
-              <a:lnSpc>
-                <a:spcPct val="90000"/>
-              </a:lnSpc>
-            </a:pPr>
-            <a:r>
-              <a:rPr sz="20000" b="1" i="0">
-                <a:solidFill>
-                  <a:srgbClr val="181715"/>
-                </a:solidFill>
-                <a:latin typeface="맑은 고딕"/>
-                <a:ea typeface="맑은 고딕"/>
-                <a:cs typeface="맑은 고딕"/>
+          <a:solidFill>
+            <a:srgbClr val="181715"/>
+          </a:solidFill>
+          <a:ln>
+            <a:noFill/>
+          </a:ln>
+          <a:effectLst/>
+        </p:spPr>
+        <p:style>
+          <a:lnRef idx="1">
+            <a:schemeClr val="accent1"/>
+          </a:lnRef>
+          <a:fillRef idx="3">
+            <a:schemeClr val="accent1"/>
+          </a:fillRef>
+          <a:effectRef idx="2">
+            <a:schemeClr val="accent1"/>
+          </a:effectRef>
+          <a:fontRef idx="minor">
+            <a:schemeClr val="lt1"/>
+          </a:fontRef>
+        </p:style>
+        <p:txBody>
+          <a:bodyPr rtlCol="0" anchor="ctr"/>
+          <a:lstStyle/>
+          <a:p>
+            <a:pPr algn="ctr"/>
+          </a:p>
+        </p:txBody>
+      </p:sp>
+      <p:sp>
+        <p:nvSpPr>
+          <p:cNvPr id="8" name="TextBox 7"/>
+          <p:cNvSpPr txBox="1"/>
+          <p:nvPr/>
+        </p:nvSpPr>
+        <p:spPr>
+          <a:xfrm>
+            <a:off x="8494776" y="1682496"/>
+            <a:ext cx="2816352" cy="274320"/>
+          </a:xfrm>
+          <a:prstGeom prst="rect">
+            <a:avLst/>
+          </a:prstGeom>
+          <a:noFill/>
+        </p:spPr>
+        <p:txBody>
+          <a:bodyPr wrap="square" anchor="t" lIns="0" rIns="0" tIns="0" bIns="0">
+            <a:spAutoFit/>
+          </a:bodyPr>
+          <a:lstStyle/>
+          <a:p>
+            <a:pPr algn="l"/>
+            <a:r>
+              <a:rPr sz="1200" b="0" spc="300">
+                <a:solidFill>
+                  <a:srgbClr val="A09D96"/>
+                </a:solidFill>
+                <a:latin typeface="맑은 고딕"/>
+                <a:ea typeface="맑은 고딕"/>
+              </a:rPr>
+              <a:t>SESSION</a:t>
+            </a:r>
+          </a:p>
+        </p:txBody>
+      </p:sp>
+      <p:sp>
+        <p:nvSpPr>
+          <p:cNvPr id="9" name="TextBox 8"/>
+          <p:cNvSpPr txBox="1"/>
+          <p:nvPr/>
+        </p:nvSpPr>
+        <p:spPr>
+          <a:xfrm>
+            <a:off x="8183879" y="1508760"/>
+            <a:ext cx="3364992" cy="3931920"/>
+          </a:xfrm>
+          <a:prstGeom prst="rect">
+            <a:avLst/>
+          </a:prstGeom>
+          <a:noFill/>
+        </p:spPr>
+        <p:txBody>
+          <a:bodyPr wrap="square" anchor="ctr" lIns="0" rIns="0" tIns="0" bIns="0">
+            <a:spAutoFit/>
+          </a:bodyPr>
+          <a:lstStyle/>
+          <a:p>
+            <a:pPr algn="ctr"/>
+            <a:r>
+              <a:rPr sz="15000" b="1">
+                <a:solidFill>
+                  <a:srgbClr val="FAF9F5"/>
+                </a:solidFill>
+                <a:latin typeface="맑은 고딕"/>
+                <a:ea typeface="맑은 고딕"/>
               </a:rPr>
               <a:t>01</a:t>
             </a:r>
@@ -3600,60 +3797,154 @@
       </p:sp>
       <p:sp>
         <p:nvSpPr>
-          <p:cNvPr id="5" name="TextBox 4"/>
-          <p:cNvSpPr txBox="1"/>
-          <p:nvPr/>
-        </p:nvSpPr>
-        <p:spPr>
-          <a:xfrm>
-            <a:off x="822960" y="1554480"/>
-            <a:ext cx="9601200" cy="1828800"/>
-          </a:xfrm>
-          <a:prstGeom prst="rect">
-            <a:avLst/>
-          </a:prstGeom>
-          <a:noFill/>
-        </p:spPr>
-        <p:txBody>
-          <a:bodyPr wrap="square" lIns="25400" rIns="25400" tIns="12700" bIns="12700" anchor="t">
-            <a:spAutoFit/>
-          </a:bodyPr>
-          <a:lstStyle/>
-          <a:p>
-            <a:pPr algn="l">
-              <a:lnSpc>
-                <a:spcPct val="115000"/>
-              </a:lnSpc>
-              <a:spcAft>
-                <a:spcPts val="1000"/>
-              </a:spcAft>
-            </a:pPr>
-            <a:r>
-              <a:rPr sz="1300" b="1" i="0" spc="200">
-                <a:solidFill>
-                  <a:srgbClr val="8E8B82"/>
-                </a:solidFill>
-                <a:latin typeface="맑은 고딕"/>
-                <a:ea typeface="맑은 고딕"/>
-                <a:cs typeface="맑은 고딕"/>
+          <p:cNvPr id="10" name="Rectangle 9"/>
+          <p:cNvSpPr/>
+          <p:nvPr/>
+        </p:nvSpPr>
+        <p:spPr>
+          <a:xfrm>
+            <a:off x="8494776" y="4617720"/>
+            <a:ext cx="2743200" cy="10972"/>
+          </a:xfrm>
+          <a:prstGeom prst="rect">
+            <a:avLst/>
+          </a:prstGeom>
+          <a:solidFill>
+            <a:srgbClr val="2A2824"/>
+          </a:solidFill>
+          <a:ln>
+            <a:noFill/>
+          </a:ln>
+          <a:effectLst/>
+        </p:spPr>
+        <p:style>
+          <a:lnRef idx="1">
+            <a:schemeClr val="accent1"/>
+          </a:lnRef>
+          <a:fillRef idx="3">
+            <a:schemeClr val="accent1"/>
+          </a:fillRef>
+          <a:effectRef idx="2">
+            <a:schemeClr val="accent1"/>
+          </a:effectRef>
+          <a:fontRef idx="minor">
+            <a:schemeClr val="lt1"/>
+          </a:fontRef>
+        </p:style>
+        <p:txBody>
+          <a:bodyPr rtlCol="0" anchor="ctr"/>
+          <a:lstStyle/>
+          <a:p>
+            <a:pPr algn="ctr"/>
+          </a:p>
+        </p:txBody>
+      </p:sp>
+      <p:sp>
+        <p:nvSpPr>
+          <p:cNvPr id="11" name="TextBox 10"/>
+          <p:cNvSpPr txBox="1"/>
+          <p:nvPr/>
+        </p:nvSpPr>
+        <p:spPr>
+          <a:xfrm>
+            <a:off x="8494776" y="4773168"/>
+            <a:ext cx="2816352" cy="457200"/>
+          </a:xfrm>
+          <a:prstGeom prst="rect">
+            <a:avLst/>
+          </a:prstGeom>
+          <a:noFill/>
+        </p:spPr>
+        <p:txBody>
+          <a:bodyPr wrap="square" anchor="t" lIns="0" rIns="0" tIns="0" bIns="0">
+            <a:spAutoFit/>
+          </a:bodyPr>
+          <a:lstStyle/>
+          <a:p>
+            <a:pPr algn="l"/>
+            <a:r>
+              <a:rPr sz="1250" b="1" spc="100">
+                <a:solidFill>
+                  <a:srgbClr val="FAF9F5"/>
+                </a:solidFill>
+                <a:latin typeface="맑은 고딕"/>
+                <a:ea typeface="맑은 고딕"/>
               </a:rPr>
               <a:t>AI SEARCH PARADIGM SHIFT</a:t>
             </a:r>
           </a:p>
-          <a:p>
-            <a:pPr algn="l">
-              <a:lnSpc>
-                <a:spcPct val="106000"/>
-              </a:lnSpc>
-            </a:pPr>
-            <a:r>
-              <a:rPr sz="3800" b="1" i="0">
+        </p:txBody>
+      </p:sp>
+      <p:sp>
+        <p:nvSpPr>
+          <p:cNvPr id="12" name="TextBox 11"/>
+          <p:cNvSpPr txBox="1"/>
+          <p:nvPr/>
+        </p:nvSpPr>
+        <p:spPr>
+          <a:xfrm>
+            <a:off x="676656" y="1755648"/>
+            <a:ext cx="7223760" cy="274320"/>
+          </a:xfrm>
+          <a:prstGeom prst="rect">
+            <a:avLst/>
+          </a:prstGeom>
+          <a:noFill/>
+        </p:spPr>
+        <p:txBody>
+          <a:bodyPr wrap="square" anchor="t" lIns="0" rIns="0" tIns="0" bIns="0">
+            <a:spAutoFit/>
+          </a:bodyPr>
+          <a:lstStyle/>
+          <a:p>
+            <a:pPr algn="l"/>
+            <a:r>
+              <a:rPr sz="1300" b="0" spc="250">
+                <a:solidFill>
+                  <a:srgbClr val="6C6A64"/>
+                </a:solidFill>
+                <a:latin typeface="맑은 고딕"/>
+                <a:ea typeface="맑은 고딕"/>
+              </a:rPr>
+              <a:t>AI SEARCH PARADIGM SHIFT</a:t>
+            </a:r>
+          </a:p>
+        </p:txBody>
+      </p:sp>
+      <p:sp>
+        <p:nvSpPr>
+          <p:cNvPr id="13" name="TextBox 12"/>
+          <p:cNvSpPr txBox="1"/>
+          <p:nvPr/>
+        </p:nvSpPr>
+        <p:spPr>
+          <a:xfrm>
+            <a:off x="658368" y="2121408"/>
+            <a:ext cx="7269480" cy="1371600"/>
+          </a:xfrm>
+          <a:prstGeom prst="rect">
+            <a:avLst/>
+          </a:prstGeom>
+          <a:noFill/>
+        </p:spPr>
+        <p:txBody>
+          <a:bodyPr wrap="square" anchor="t" lIns="0" rIns="0" tIns="0" bIns="0">
+            <a:spAutoFit/>
+          </a:bodyPr>
+          <a:lstStyle/>
+          <a:p>
+            <a:pPr algn="l">
+              <a:lnSpc>
+                <a:spcPct val="105000"/>
+              </a:lnSpc>
+            </a:pPr>
+            <a:r>
+              <a:rPr sz="3700" b="1">
                 <a:solidFill>
                   <a:srgbClr val="141413"/>
                 </a:solidFill>
                 <a:latin typeface="맑은 고딕"/>
                 <a:ea typeface="맑은 고딕"/>
-                <a:cs typeface="맑은 고딕"/>
               </a:rPr>
               <a:t>AI 검색 패러다임의 전환</a:t>
             </a:r>
@@ -3662,17 +3953,19 @@
       </p:sp>
       <p:sp>
         <p:nvSpPr>
-          <p:cNvPr id="6" name="Rectangle 5"/>
+          <p:cNvPr id="14" name="Rounded Rectangle 13"/>
           <p:cNvSpPr/>
           <p:nvPr/>
         </p:nvSpPr>
         <p:spPr>
           <a:xfrm>
-            <a:off x="868680" y="3611880"/>
-            <a:ext cx="1828800" cy="23774"/>
-          </a:xfrm>
-          <a:prstGeom prst="rect">
-            <a:avLst/>
+            <a:off x="694944" y="3611880"/>
+            <a:ext cx="713232" cy="45720"/>
+          </a:xfrm>
+          <a:prstGeom prst="roundRect">
+            <a:avLst>
+              <a:gd name="adj" fmla="val 50000"/>
+            </a:avLst>
           </a:prstGeom>
           <a:solidFill>
             <a:srgbClr val="F37021"/>
@@ -3706,39 +3999,38 @@
       </p:sp>
       <p:sp>
         <p:nvSpPr>
-          <p:cNvPr id="7" name="TextBox 6"/>
-          <p:cNvSpPr txBox="1"/>
-          <p:nvPr/>
-        </p:nvSpPr>
-        <p:spPr>
-          <a:xfrm>
-            <a:off x="868680" y="3840480"/>
-            <a:ext cx="9692640" cy="914400"/>
-          </a:xfrm>
-          <a:prstGeom prst="rect">
-            <a:avLst/>
-          </a:prstGeom>
-          <a:noFill/>
-        </p:spPr>
-        <p:txBody>
-          <a:bodyPr wrap="square" lIns="25400" rIns="25400" tIns="12700" bIns="12700" anchor="t">
-            <a:spAutoFit/>
-          </a:bodyPr>
-          <a:lstStyle/>
-          <a:p>
-            <a:pPr algn="l">
-              <a:lnSpc>
-                <a:spcPct val="140000"/>
-              </a:lnSpc>
-            </a:pPr>
-            <a:r>
-              <a:rPr sz="1400" b="0" i="0">
-                <a:solidFill>
-                  <a:srgbClr val="6C6A64"/>
-                </a:solidFill>
-                <a:latin typeface="맑은 고딕"/>
-                <a:ea typeface="맑은 고딕"/>
-                <a:cs typeface="맑은 고딕"/>
+          <p:cNvPr id="15" name="TextBox 14"/>
+          <p:cNvSpPr txBox="1"/>
+          <p:nvPr/>
+        </p:nvSpPr>
+        <p:spPr>
+          <a:xfrm>
+            <a:off x="676656" y="3822191"/>
+            <a:ext cx="7040880" cy="822960"/>
+          </a:xfrm>
+          <a:prstGeom prst="rect">
+            <a:avLst/>
+          </a:prstGeom>
+          <a:noFill/>
+        </p:spPr>
+        <p:txBody>
+          <a:bodyPr wrap="square" anchor="t" lIns="0" rIns="0" tIns="0" bIns="0">
+            <a:spAutoFit/>
+          </a:bodyPr>
+          <a:lstStyle/>
+          <a:p>
+            <a:pPr algn="l">
+              <a:lnSpc>
+                <a:spcPct val="130000"/>
+              </a:lnSpc>
+            </a:pPr>
+            <a:r>
+              <a:rPr sz="1450" b="0">
+                <a:solidFill>
+                  <a:srgbClr val="3D3D3A"/>
+                </a:solidFill>
+                <a:latin typeface="맑은 고딕"/>
+                <a:ea typeface="맑은 고딕"/>
               </a:rPr>
               <a:t>검색은 더 이상 '링크 목록'이 아니다. AI가 직접 답을 만드는 시대, 가장 먼저 다시 세워야 할 '가시성의 문법'.</a:t>
             </a:r>
@@ -3747,17 +4039,19 @@
       </p:sp>
       <p:sp>
         <p:nvSpPr>
-          <p:cNvPr id="8" name="Oval 7"/>
+          <p:cNvPr id="16" name="Rounded Rectangle 15"/>
           <p:cNvSpPr/>
           <p:nvPr/>
         </p:nvSpPr>
         <p:spPr>
           <a:xfrm>
-            <a:off x="886968" y="4901183"/>
-            <a:ext cx="109728" cy="109728"/>
-          </a:xfrm>
-          <a:prstGeom prst="ellipse">
-            <a:avLst/>
+            <a:off x="694944" y="4754880"/>
+            <a:ext cx="91440" cy="91440"/>
+          </a:xfrm>
+          <a:prstGeom prst="roundRect">
+            <a:avLst>
+              <a:gd name="adj" fmla="val 25000"/>
+            </a:avLst>
           </a:prstGeom>
           <a:solidFill>
             <a:srgbClr val="F37021"/>
@@ -3791,39 +4085,34 @@
       </p:sp>
       <p:sp>
         <p:nvSpPr>
-          <p:cNvPr id="9" name="TextBox 8"/>
-          <p:cNvSpPr txBox="1"/>
-          <p:nvPr/>
-        </p:nvSpPr>
-        <p:spPr>
-          <a:xfrm>
-            <a:off x="1188720" y="4846320"/>
-            <a:ext cx="9692640" cy="384048"/>
-          </a:xfrm>
-          <a:prstGeom prst="rect">
-            <a:avLst/>
-          </a:prstGeom>
-          <a:noFill/>
-        </p:spPr>
-        <p:txBody>
-          <a:bodyPr wrap="square" lIns="25400" rIns="25400" tIns="12700" bIns="12700" anchor="ctr">
-            <a:spAutoFit/>
-          </a:bodyPr>
-          <a:lstStyle/>
-          <a:p>
-            <a:pPr algn="l">
-              <a:lnSpc>
-                <a:spcPct val="125000"/>
-              </a:lnSpc>
-            </a:pPr>
-            <a:r>
-              <a:rPr sz="1200" b="0" i="0">
-                <a:solidFill>
-                  <a:srgbClr val="6C6A64"/>
-                </a:solidFill>
-                <a:latin typeface="맑은 고딕"/>
-                <a:ea typeface="맑은 고딕"/>
-                <a:cs typeface="맑은 고딕"/>
+          <p:cNvPr id="17" name="TextBox 16"/>
+          <p:cNvSpPr txBox="1"/>
+          <p:nvPr/>
+        </p:nvSpPr>
+        <p:spPr>
+          <a:xfrm>
+            <a:off x="932688" y="4663440"/>
+            <a:ext cx="6766560" cy="365760"/>
+          </a:xfrm>
+          <a:prstGeom prst="rect">
+            <a:avLst/>
+          </a:prstGeom>
+          <a:noFill/>
+        </p:spPr>
+        <p:txBody>
+          <a:bodyPr wrap="square" anchor="t" lIns="0" rIns="0" tIns="0" bIns="0">
+            <a:spAutoFit/>
+          </a:bodyPr>
+          <a:lstStyle/>
+          <a:p>
+            <a:pPr algn="l"/>
+            <a:r>
+              <a:rPr sz="1250" b="0">
+                <a:solidFill>
+                  <a:srgbClr val="252523"/>
+                </a:solidFill>
+                <a:latin typeface="맑은 고딕"/>
+                <a:ea typeface="맑은 고딕"/>
               </a:rPr>
               <a:t>140년 미디어·검색史로 보는 패러다임 이동의 패턴</a:t>
             </a:r>
@@ -3832,17 +4121,19 @@
       </p:sp>
       <p:sp>
         <p:nvSpPr>
-          <p:cNvPr id="10" name="Oval 9"/>
+          <p:cNvPr id="18" name="Rounded Rectangle 17"/>
           <p:cNvSpPr/>
           <p:nvPr/>
         </p:nvSpPr>
         <p:spPr>
           <a:xfrm>
-            <a:off x="886968" y="5303520"/>
-            <a:ext cx="109728" cy="109728"/>
-          </a:xfrm>
-          <a:prstGeom prst="ellipse">
-            <a:avLst/>
+            <a:off x="694944" y="5138928"/>
+            <a:ext cx="91440" cy="91440"/>
+          </a:xfrm>
+          <a:prstGeom prst="roundRect">
+            <a:avLst>
+              <a:gd name="adj" fmla="val 25000"/>
+            </a:avLst>
           </a:prstGeom>
           <a:solidFill>
             <a:srgbClr val="F37021"/>
@@ -3876,39 +4167,34 @@
       </p:sp>
       <p:sp>
         <p:nvSpPr>
-          <p:cNvPr id="11" name="TextBox 10"/>
-          <p:cNvSpPr txBox="1"/>
-          <p:nvPr/>
-        </p:nvSpPr>
-        <p:spPr>
-          <a:xfrm>
-            <a:off x="1188720" y="5248656"/>
-            <a:ext cx="9692640" cy="384048"/>
-          </a:xfrm>
-          <a:prstGeom prst="rect">
-            <a:avLst/>
-          </a:prstGeom>
-          <a:noFill/>
-        </p:spPr>
-        <p:txBody>
-          <a:bodyPr wrap="square" lIns="25400" rIns="25400" tIns="12700" bIns="12700" anchor="ctr">
-            <a:spAutoFit/>
-          </a:bodyPr>
-          <a:lstStyle/>
-          <a:p>
-            <a:pPr algn="l">
-              <a:lnSpc>
-                <a:spcPct val="125000"/>
-              </a:lnSpc>
-            </a:pPr>
-            <a:r>
-              <a:rPr sz="1200" b="0" i="0">
-                <a:solidFill>
-                  <a:srgbClr val="6C6A64"/>
-                </a:solidFill>
-                <a:latin typeface="맑은 고딕"/>
-                <a:ea typeface="맑은 고딕"/>
-                <a:cs typeface="맑은 고딕"/>
+          <p:cNvPr id="19" name="TextBox 18"/>
+          <p:cNvSpPr txBox="1"/>
+          <p:nvPr/>
+        </p:nvSpPr>
+        <p:spPr>
+          <a:xfrm>
+            <a:off x="932688" y="5047488"/>
+            <a:ext cx="6766560" cy="365760"/>
+          </a:xfrm>
+          <a:prstGeom prst="rect">
+            <a:avLst/>
+          </a:prstGeom>
+          <a:noFill/>
+        </p:spPr>
+        <p:txBody>
+          <a:bodyPr wrap="square" anchor="t" lIns="0" rIns="0" tIns="0" bIns="0">
+            <a:spAutoFit/>
+          </a:bodyPr>
+          <a:lstStyle/>
+          <a:p>
+            <a:pPr algn="l"/>
+            <a:r>
+              <a:rPr sz="1250" b="0">
+                <a:solidFill>
+                  <a:srgbClr val="252523"/>
+                </a:solidFill>
+                <a:latin typeface="맑은 고딕"/>
+                <a:ea typeface="맑은 고딕"/>
               </a:rPr>
               <a:t>SEO → AEO → GEO, 발견·채택·인용의 3단계 모델</a:t>
             </a:r>
@@ -3917,17 +4203,19 @@
       </p:sp>
       <p:sp>
         <p:nvSpPr>
-          <p:cNvPr id="12" name="Oval 11"/>
+          <p:cNvPr id="20" name="Rounded Rectangle 19"/>
           <p:cNvSpPr/>
           <p:nvPr/>
         </p:nvSpPr>
         <p:spPr>
           <a:xfrm>
-            <a:off x="886968" y="5705856"/>
-            <a:ext cx="109728" cy="109728"/>
-          </a:xfrm>
-          <a:prstGeom prst="ellipse">
-            <a:avLst/>
+            <a:off x="694944" y="5522976"/>
+            <a:ext cx="91440" cy="91440"/>
+          </a:xfrm>
+          <a:prstGeom prst="roundRect">
+            <a:avLst>
+              <a:gd name="adj" fmla="val 25000"/>
+            </a:avLst>
           </a:prstGeom>
           <a:solidFill>
             <a:srgbClr val="F37021"/>
@@ -3961,39 +4249,34 @@
       </p:sp>
       <p:sp>
         <p:nvSpPr>
-          <p:cNvPr id="13" name="TextBox 12"/>
-          <p:cNvSpPr txBox="1"/>
-          <p:nvPr/>
-        </p:nvSpPr>
-        <p:spPr>
-          <a:xfrm>
-            <a:off x="1188720" y="5650992"/>
-            <a:ext cx="9692640" cy="384048"/>
-          </a:xfrm>
-          <a:prstGeom prst="rect">
-            <a:avLst/>
-          </a:prstGeom>
-          <a:noFill/>
-        </p:spPr>
-        <p:txBody>
-          <a:bodyPr wrap="square" lIns="25400" rIns="25400" tIns="12700" bIns="12700" anchor="ctr">
-            <a:spAutoFit/>
-          </a:bodyPr>
-          <a:lstStyle/>
-          <a:p>
-            <a:pPr algn="l">
-              <a:lnSpc>
-                <a:spcPct val="125000"/>
-              </a:lnSpc>
-            </a:pPr>
-            <a:r>
-              <a:rPr sz="1200" b="0" i="0">
-                <a:solidFill>
-                  <a:srgbClr val="6C6A64"/>
-                </a:solidFill>
-                <a:latin typeface="맑은 고딕"/>
-                <a:ea typeface="맑은 고딕"/>
-                <a:cs typeface="맑은 고딕"/>
+          <p:cNvPr id="21" name="TextBox 20"/>
+          <p:cNvSpPr txBox="1"/>
+          <p:nvPr/>
+        </p:nvSpPr>
+        <p:spPr>
+          <a:xfrm>
+            <a:off x="932688" y="5431536"/>
+            <a:ext cx="6766560" cy="365760"/>
+          </a:xfrm>
+          <a:prstGeom prst="rect">
+            <a:avLst/>
+          </a:prstGeom>
+          <a:noFill/>
+        </p:spPr>
+        <p:txBody>
+          <a:bodyPr wrap="square" anchor="t" lIns="0" rIns="0" tIns="0" bIns="0">
+            <a:spAutoFit/>
+          </a:bodyPr>
+          <a:lstStyle/>
+          <a:p>
+            <a:pPr algn="l"/>
+            <a:r>
+              <a:rPr sz="1250" b="0">
+                <a:solidFill>
+                  <a:srgbClr val="252523"/>
+                </a:solidFill>
+                <a:latin typeface="맑은 고딕"/>
+                <a:ea typeface="맑은 고딕"/>
               </a:rPr>
               <a:t>AI는 콘텐츠를 키워드가 아니라 '의미'로 평가한다</a:t>
             </a:r>
@@ -4002,17 +4285,19 @@
       </p:sp>
       <p:sp>
         <p:nvSpPr>
-          <p:cNvPr id="14" name="Oval 13"/>
+          <p:cNvPr id="22" name="Rounded Rectangle 21"/>
           <p:cNvSpPr/>
           <p:nvPr/>
         </p:nvSpPr>
         <p:spPr>
           <a:xfrm>
-            <a:off x="886968" y="6108192"/>
-            <a:ext cx="109728" cy="109728"/>
-          </a:xfrm>
-          <a:prstGeom prst="ellipse">
-            <a:avLst/>
+            <a:off x="694944" y="5907024"/>
+            <a:ext cx="91440" cy="91440"/>
+          </a:xfrm>
+          <a:prstGeom prst="roundRect">
+            <a:avLst>
+              <a:gd name="adj" fmla="val 25000"/>
+            </a:avLst>
           </a:prstGeom>
           <a:solidFill>
             <a:srgbClr val="F37021"/>
@@ -4046,39 +4331,34 @@
       </p:sp>
       <p:sp>
         <p:nvSpPr>
-          <p:cNvPr id="15" name="TextBox 14"/>
-          <p:cNvSpPr txBox="1"/>
-          <p:nvPr/>
-        </p:nvSpPr>
-        <p:spPr>
-          <a:xfrm>
-            <a:off x="1188720" y="6053328"/>
-            <a:ext cx="9692640" cy="384048"/>
-          </a:xfrm>
-          <a:prstGeom prst="rect">
-            <a:avLst/>
-          </a:prstGeom>
-          <a:noFill/>
-        </p:spPr>
-        <p:txBody>
-          <a:bodyPr wrap="square" lIns="25400" rIns="25400" tIns="12700" bIns="12700" anchor="ctr">
-            <a:spAutoFit/>
-          </a:bodyPr>
-          <a:lstStyle/>
-          <a:p>
-            <a:pPr algn="l">
-              <a:lnSpc>
-                <a:spcPct val="125000"/>
-              </a:lnSpc>
-            </a:pPr>
-            <a:r>
-              <a:rPr sz="1200" b="0" i="0">
-                <a:solidFill>
-                  <a:srgbClr val="6C6A64"/>
-                </a:solidFill>
-                <a:latin typeface="맑은 고딕"/>
-                <a:ea typeface="맑은 고딕"/>
-                <a:cs typeface="맑은 고딕"/>
+          <p:cNvPr id="23" name="TextBox 22"/>
+          <p:cNvSpPr txBox="1"/>
+          <p:nvPr/>
+        </p:nvSpPr>
+        <p:spPr>
+          <a:xfrm>
+            <a:off x="932688" y="5815584"/>
+            <a:ext cx="6766560" cy="365760"/>
+          </a:xfrm>
+          <a:prstGeom prst="rect">
+            <a:avLst/>
+          </a:prstGeom>
+          <a:noFill/>
+        </p:spPr>
+        <p:txBody>
+          <a:bodyPr wrap="square" anchor="t" lIns="0" rIns="0" tIns="0" bIns="0">
+            <a:spAutoFit/>
+          </a:bodyPr>
+          <a:lstStyle/>
+          <a:p>
+            <a:pPr algn="l"/>
+            <a:r>
+              <a:rPr sz="1250" b="0">
+                <a:solidFill>
+                  <a:srgbClr val="252523"/>
+                </a:solidFill>
+                <a:latin typeface="맑은 고딕"/>
+                <a:ea typeface="맑은 고딕"/>
               </a:rPr>
               <a:t>2026년 최신 데이터로 확인하는 AI 검색의 현재 위치</a:t>
             </a:r>
@@ -4087,41 +4367,116 @@
       </p:sp>
       <p:sp>
         <p:nvSpPr>
-          <p:cNvPr id="16" name="TextBox 15"/>
-          <p:cNvSpPr txBox="1"/>
-          <p:nvPr/>
-        </p:nvSpPr>
-        <p:spPr>
-          <a:xfrm>
-            <a:off x="868680" y="6437376"/>
-            <a:ext cx="8229600" cy="274320"/>
-          </a:xfrm>
-          <a:prstGeom prst="rect">
-            <a:avLst/>
-          </a:prstGeom>
-          <a:noFill/>
-        </p:spPr>
-        <p:txBody>
-          <a:bodyPr wrap="square" lIns="25400" rIns="25400" tIns="12700" bIns="12700" anchor="t">
-            <a:spAutoFit/>
-          </a:bodyPr>
-          <a:lstStyle/>
-          <a:p>
-            <a:pPr algn="l">
-              <a:lnSpc>
-                <a:spcPct val="115000"/>
-              </a:lnSpc>
-            </a:pPr>
-            <a:r>
-              <a:rPr sz="850" b="0" i="0" spc="100">
+          <p:cNvPr id="24" name="Rectangle 23"/>
+          <p:cNvSpPr/>
+          <p:nvPr/>
+        </p:nvSpPr>
+        <p:spPr>
+          <a:xfrm>
+            <a:off x="658368" y="6419088"/>
+            <a:ext cx="10890504" cy="9144"/>
+          </a:xfrm>
+          <a:prstGeom prst="rect">
+            <a:avLst/>
+          </a:prstGeom>
+          <a:solidFill>
+            <a:srgbClr val="E6DFD8"/>
+          </a:solidFill>
+          <a:ln>
+            <a:noFill/>
+          </a:ln>
+          <a:effectLst/>
+        </p:spPr>
+        <p:style>
+          <a:lnRef idx="1">
+            <a:schemeClr val="accent1"/>
+          </a:lnRef>
+          <a:fillRef idx="3">
+            <a:schemeClr val="accent1"/>
+          </a:fillRef>
+          <a:effectRef idx="2">
+            <a:schemeClr val="accent1"/>
+          </a:effectRef>
+          <a:fontRef idx="minor">
+            <a:schemeClr val="lt1"/>
+          </a:fontRef>
+        </p:style>
+        <p:txBody>
+          <a:bodyPr rtlCol="0" anchor="ctr"/>
+          <a:lstStyle/>
+          <a:p>
+            <a:pPr algn="ctr"/>
+          </a:p>
+        </p:txBody>
+      </p:sp>
+      <p:sp>
+        <p:nvSpPr>
+          <p:cNvPr id="25" name="TextBox 24"/>
+          <p:cNvSpPr txBox="1"/>
+          <p:nvPr/>
+        </p:nvSpPr>
+        <p:spPr>
+          <a:xfrm>
+            <a:off x="658368" y="6473952"/>
+            <a:ext cx="6400800" cy="274320"/>
+          </a:xfrm>
+          <a:prstGeom prst="rect">
+            <a:avLst/>
+          </a:prstGeom>
+          <a:noFill/>
+        </p:spPr>
+        <p:txBody>
+          <a:bodyPr wrap="square" anchor="t" lIns="0" rIns="0" tIns="0" bIns="0">
+            <a:spAutoFit/>
+          </a:bodyPr>
+          <a:lstStyle/>
+          <a:p>
+            <a:pPr algn="l"/>
+            <a:r>
+              <a:rPr sz="900" b="0" spc="50">
                 <a:solidFill>
                   <a:srgbClr val="8E8B82"/>
                 </a:solidFill>
                 <a:latin typeface="맑은 고딕"/>
                 <a:ea typeface="맑은 고딕"/>
-                <a:cs typeface="맑은 고딕"/>
-              </a:rPr>
-              <a:t>AI 검색 시대 마케팅 — SEO·AEO·GEO 6강 완성 과정</a:t>
+              </a:rPr>
+              <a:t>SEO · AEO · GEO — AI 검색 시대 마케팅</a:t>
+            </a:r>
+          </a:p>
+        </p:txBody>
+      </p:sp>
+      <p:sp>
+        <p:nvSpPr>
+          <p:cNvPr id="26" name="TextBox 25"/>
+          <p:cNvSpPr txBox="1"/>
+          <p:nvPr/>
+        </p:nvSpPr>
+        <p:spPr>
+          <a:xfrm>
+            <a:off x="8229600" y="6473952"/>
+            <a:ext cx="3319272" cy="274320"/>
+          </a:xfrm>
+          <a:prstGeom prst="rect">
+            <a:avLst/>
+          </a:prstGeom>
+          <a:noFill/>
+        </p:spPr>
+        <p:txBody>
+          <a:bodyPr wrap="square" anchor="t" lIns="0" rIns="0" tIns="0" bIns="0">
+            <a:spAutoFit/>
+          </a:bodyPr>
+          <a:lstStyle/>
+          <a:p>
+            <a:pPr algn="r"/>
+            <a:r>
+              <a:rPr sz="900" b="0" spc="80">
+                <a:solidFill>
+                  <a:srgbClr val="8E8B82"/>
+                </a:solidFill>
+                <a:latin typeface="맑은 고딕"/>
+                <a:ea typeface="맑은 고딕"/>
+              </a:rPr>
+              <a:t>01 / 06</a:t>
             </a:r>
           </a:p>
         </p:txBody>
@@ -27748,6 +28103,1832 @@
           <a:bodyPr/>
           <a:lstStyle/>
           <a:p/>
+        </p:txBody>
+      </p:sp>
+    </p:spTree>
+  </p:cSld>
+  <p:clrMapOvr>
+    <a:masterClrMapping/>
+  </p:clrMapOvr>
+</p:sld>
+</file>
+
+<file path=ppt/slides/slide39.xml><?xml version="1.0" encoding="utf-8"?>
+<p:sld xmlns:a="http://schemas.openxmlformats.org/drawingml/2006/main" xmlns:p="http://schemas.openxmlformats.org/presentationml/2006/main" xmlns:r="http://schemas.openxmlformats.org/officeDocument/2006/relationships">
+  <p:cSld>
+    <p:spTree>
+      <p:nvGrpSpPr>
+        <p:cNvPr id="1" name=""/>
+        <p:cNvGrpSpPr/>
+        <p:nvPr/>
+      </p:nvGrpSpPr>
+      <p:grpSpPr/>
+      <p:sp>
+        <p:nvSpPr>
+          <p:cNvPr id="2" name="Rectangle 1"/>
+          <p:cNvSpPr/>
+          <p:nvPr/>
+        </p:nvSpPr>
+        <p:spPr>
+          <a:xfrm>
+            <a:off x="0" y="0"/>
+            <a:ext cx="12191695" cy="6858000"/>
+          </a:xfrm>
+          <a:prstGeom prst="rect">
+            <a:avLst/>
+          </a:prstGeom>
+          <a:solidFill>
+            <a:srgbClr val="FAF9F5"/>
+          </a:solidFill>
+          <a:ln>
+            <a:noFill/>
+          </a:ln>
+          <a:effectLst/>
+        </p:spPr>
+        <p:style>
+          <a:lnRef idx="1">
+            <a:schemeClr val="accent1"/>
+          </a:lnRef>
+          <a:fillRef idx="3">
+            <a:schemeClr val="accent1"/>
+          </a:fillRef>
+          <a:effectRef idx="2">
+            <a:schemeClr val="accent1"/>
+          </a:effectRef>
+          <a:fontRef idx="minor">
+            <a:schemeClr val="lt1"/>
+          </a:fontRef>
+        </p:style>
+        <p:txBody>
+          <a:bodyPr rtlCol="0" anchor="ctr"/>
+          <a:lstStyle/>
+          <a:p>
+            <a:pPr algn="ctr"/>
+          </a:p>
+        </p:txBody>
+      </p:sp>
+      <p:sp>
+        <p:nvSpPr>
+          <p:cNvPr id="3" name="TextBox 2"/>
+          <p:cNvSpPr txBox="1"/>
+          <p:nvPr/>
+        </p:nvSpPr>
+        <p:spPr>
+          <a:xfrm>
+            <a:off x="658368" y="530352"/>
+            <a:ext cx="9144000" cy="274320"/>
+          </a:xfrm>
+          <a:prstGeom prst="rect">
+            <a:avLst/>
+          </a:prstGeom>
+          <a:noFill/>
+        </p:spPr>
+        <p:txBody>
+          <a:bodyPr wrap="square" anchor="t" lIns="0" rIns="0" tIns="0" bIns="0">
+            <a:spAutoFit/>
+          </a:bodyPr>
+          <a:lstStyle/>
+          <a:p>
+            <a:pPr algn="l"/>
+            <a:r>
+              <a:rPr sz="1100" b="0" spc="120">
+                <a:solidFill>
+                  <a:srgbClr val="6C6A64"/>
+                </a:solidFill>
+                <a:latin typeface="맑은 고딕"/>
+                <a:ea typeface="맑은 고딕"/>
+              </a:rPr>
+              <a:t>SEO · AEO · GEO · 6강 커리큘럼</a:t>
+            </a:r>
+          </a:p>
+        </p:txBody>
+      </p:sp>
+      <p:sp>
+        <p:nvSpPr>
+          <p:cNvPr id="4" name="TextBox 3"/>
+          <p:cNvSpPr txBox="1"/>
+          <p:nvPr/>
+        </p:nvSpPr>
+        <p:spPr>
+          <a:xfrm>
+            <a:off x="640080" y="896112"/>
+            <a:ext cx="10881360" cy="640080"/>
+          </a:xfrm>
+          <a:prstGeom prst="rect">
+            <a:avLst/>
+          </a:prstGeom>
+          <a:noFill/>
+        </p:spPr>
+        <p:txBody>
+          <a:bodyPr wrap="square" anchor="t" lIns="0" rIns="0" tIns="0" bIns="0">
+            <a:spAutoFit/>
+          </a:bodyPr>
+          <a:lstStyle/>
+          <a:p>
+            <a:pPr algn="l"/>
+            <a:r>
+              <a:rPr sz="2700" b="1">
+                <a:solidFill>
+                  <a:srgbClr val="141413"/>
+                </a:solidFill>
+                <a:latin typeface="맑은 고딕"/>
+                <a:ea typeface="맑은 고딕"/>
+              </a:rPr>
+              <a:t>6강으로 완성하는 AI 검색 시대 마케팅</a:t>
+            </a:r>
+          </a:p>
+        </p:txBody>
+      </p:sp>
+      <p:sp>
+        <p:nvSpPr>
+          <p:cNvPr id="5" name="Rectangle 4"/>
+          <p:cNvSpPr/>
+          <p:nvPr/>
+        </p:nvSpPr>
+        <p:spPr>
+          <a:xfrm>
+            <a:off x="658368" y="1664208"/>
+            <a:ext cx="10890504" cy="12801"/>
+          </a:xfrm>
+          <a:prstGeom prst="rect">
+            <a:avLst/>
+          </a:prstGeom>
+          <a:solidFill>
+            <a:srgbClr val="E6DFD8"/>
+          </a:solidFill>
+          <a:ln>
+            <a:noFill/>
+          </a:ln>
+          <a:effectLst/>
+        </p:spPr>
+        <p:style>
+          <a:lnRef idx="1">
+            <a:schemeClr val="accent1"/>
+          </a:lnRef>
+          <a:fillRef idx="3">
+            <a:schemeClr val="accent1"/>
+          </a:fillRef>
+          <a:effectRef idx="2">
+            <a:schemeClr val="accent1"/>
+          </a:effectRef>
+          <a:fontRef idx="minor">
+            <a:schemeClr val="lt1"/>
+          </a:fontRef>
+        </p:style>
+        <p:txBody>
+          <a:bodyPr rtlCol="0" anchor="ctr"/>
+          <a:lstStyle/>
+          <a:p>
+            <a:pPr algn="ctr"/>
+          </a:p>
+        </p:txBody>
+      </p:sp>
+      <p:sp>
+        <p:nvSpPr>
+          <p:cNvPr id="6" name="Rounded Rectangle 5"/>
+          <p:cNvSpPr/>
+          <p:nvPr/>
+        </p:nvSpPr>
+        <p:spPr>
+          <a:xfrm>
+            <a:off x="658368" y="1655064"/>
+            <a:ext cx="658368" cy="27432"/>
+          </a:xfrm>
+          <a:prstGeom prst="roundRect">
+            <a:avLst>
+              <a:gd name="adj" fmla="val 50000"/>
+            </a:avLst>
+          </a:prstGeom>
+          <a:solidFill>
+            <a:srgbClr val="F37021"/>
+          </a:solidFill>
+          <a:ln>
+            <a:noFill/>
+          </a:ln>
+          <a:effectLst/>
+        </p:spPr>
+        <p:style>
+          <a:lnRef idx="1">
+            <a:schemeClr val="accent1"/>
+          </a:lnRef>
+          <a:fillRef idx="3">
+            <a:schemeClr val="accent1"/>
+          </a:fillRef>
+          <a:effectRef idx="2">
+            <a:schemeClr val="accent1"/>
+          </a:effectRef>
+          <a:fontRef idx="minor">
+            <a:schemeClr val="lt1"/>
+          </a:fontRef>
+        </p:style>
+        <p:txBody>
+          <a:bodyPr rtlCol="0" anchor="ctr"/>
+          <a:lstStyle/>
+          <a:p>
+            <a:pPr algn="ctr"/>
+          </a:p>
+        </p:txBody>
+      </p:sp>
+      <p:sp>
+        <p:nvSpPr>
+          <p:cNvPr id="7" name="TextBox 6"/>
+          <p:cNvSpPr txBox="1"/>
+          <p:nvPr/>
+        </p:nvSpPr>
+        <p:spPr>
+          <a:xfrm>
+            <a:off x="658368" y="1792224"/>
+            <a:ext cx="10881360" cy="320040"/>
+          </a:xfrm>
+          <a:prstGeom prst="rect">
+            <a:avLst/>
+          </a:prstGeom>
+          <a:noFill/>
+        </p:spPr>
+        <p:txBody>
+          <a:bodyPr wrap="square" anchor="t" lIns="0" rIns="0" tIns="0" bIns="0">
+            <a:spAutoFit/>
+          </a:bodyPr>
+          <a:lstStyle/>
+          <a:p>
+            <a:pPr algn="l"/>
+            <a:r>
+              <a:rPr sz="1250" b="0">
+                <a:solidFill>
+                  <a:srgbClr val="6C6A64"/>
+                </a:solidFill>
+                <a:latin typeface="맑은 고딕"/>
+                <a:ea typeface="맑은 고딕"/>
+              </a:rPr>
+              <a:t>기초 → 콘텐츠 → 신뢰 → 통합까지, 6단계로 쌓아 올리는 실전 로드맵</a:t>
+            </a:r>
+          </a:p>
+        </p:txBody>
+      </p:sp>
+      <p:sp>
+        <p:nvSpPr>
+          <p:cNvPr id="8" name="Rounded Rectangle 7"/>
+          <p:cNvSpPr/>
+          <p:nvPr/>
+        </p:nvSpPr>
+        <p:spPr>
+          <a:xfrm>
+            <a:off x="658368" y="2286000"/>
+            <a:ext cx="3496056" cy="1856232"/>
+          </a:xfrm>
+          <a:prstGeom prst="roundRect">
+            <a:avLst>
+              <a:gd name="adj" fmla="val 6000"/>
+            </a:avLst>
+          </a:prstGeom>
+          <a:solidFill>
+            <a:srgbClr val="181715"/>
+          </a:solidFill>
+          <a:ln>
+            <a:noFill/>
+          </a:ln>
+          <a:effectLst/>
+        </p:spPr>
+        <p:style>
+          <a:lnRef idx="1">
+            <a:schemeClr val="accent1"/>
+          </a:lnRef>
+          <a:fillRef idx="3">
+            <a:schemeClr val="accent1"/>
+          </a:fillRef>
+          <a:effectRef idx="2">
+            <a:schemeClr val="accent1"/>
+          </a:effectRef>
+          <a:fontRef idx="minor">
+            <a:schemeClr val="lt1"/>
+          </a:fontRef>
+        </p:style>
+        <p:txBody>
+          <a:bodyPr rtlCol="0" anchor="ctr"/>
+          <a:lstStyle/>
+          <a:p>
+            <a:pPr algn="ctr"/>
+          </a:p>
+        </p:txBody>
+      </p:sp>
+      <p:sp>
+        <p:nvSpPr>
+          <p:cNvPr id="9" name="Rounded Rectangle 8"/>
+          <p:cNvSpPr/>
+          <p:nvPr/>
+        </p:nvSpPr>
+        <p:spPr>
+          <a:xfrm>
+            <a:off x="932688" y="2560320"/>
+            <a:ext cx="237744" cy="41148"/>
+          </a:xfrm>
+          <a:prstGeom prst="roundRect">
+            <a:avLst>
+              <a:gd name="adj" fmla="val 50000"/>
+            </a:avLst>
+          </a:prstGeom>
+          <a:solidFill>
+            <a:srgbClr val="F37021"/>
+          </a:solidFill>
+          <a:ln>
+            <a:noFill/>
+          </a:ln>
+          <a:effectLst/>
+        </p:spPr>
+        <p:style>
+          <a:lnRef idx="1">
+            <a:schemeClr val="accent1"/>
+          </a:lnRef>
+          <a:fillRef idx="3">
+            <a:schemeClr val="accent1"/>
+          </a:fillRef>
+          <a:effectRef idx="2">
+            <a:schemeClr val="accent1"/>
+          </a:effectRef>
+          <a:fontRef idx="minor">
+            <a:schemeClr val="lt1"/>
+          </a:fontRef>
+        </p:style>
+        <p:txBody>
+          <a:bodyPr rtlCol="0" anchor="ctr"/>
+          <a:lstStyle/>
+          <a:p>
+            <a:pPr algn="ctr"/>
+          </a:p>
+        </p:txBody>
+      </p:sp>
+      <p:sp>
+        <p:nvSpPr>
+          <p:cNvPr id="10" name="TextBox 9"/>
+          <p:cNvSpPr txBox="1"/>
+          <p:nvPr/>
+        </p:nvSpPr>
+        <p:spPr>
+          <a:xfrm>
+            <a:off x="914400" y="2651760"/>
+            <a:ext cx="3038856" cy="502920"/>
+          </a:xfrm>
+          <a:prstGeom prst="rect">
+            <a:avLst/>
+          </a:prstGeom>
+          <a:noFill/>
+        </p:spPr>
+        <p:txBody>
+          <a:bodyPr wrap="square" anchor="t" lIns="0" rIns="0" tIns="0" bIns="0">
+            <a:spAutoFit/>
+          </a:bodyPr>
+          <a:lstStyle/>
+          <a:p>
+            <a:pPr algn="l"/>
+            <a:r>
+              <a:rPr sz="3200" b="1">
+                <a:solidFill>
+                  <a:srgbClr val="FAF9F5"/>
+                </a:solidFill>
+                <a:latin typeface="맑은 고딕"/>
+                <a:ea typeface="맑은 고딕"/>
+              </a:rPr>
+              <a:t>01</a:t>
+            </a:r>
+          </a:p>
+        </p:txBody>
+      </p:sp>
+      <p:sp>
+        <p:nvSpPr>
+          <p:cNvPr id="11" name="TextBox 10"/>
+          <p:cNvSpPr txBox="1"/>
+          <p:nvPr/>
+        </p:nvSpPr>
+        <p:spPr>
+          <a:xfrm>
+            <a:off x="932688" y="3255264"/>
+            <a:ext cx="2993136" cy="256032"/>
+          </a:xfrm>
+          <a:prstGeom prst="rect">
+            <a:avLst/>
+          </a:prstGeom>
+          <a:noFill/>
+        </p:spPr>
+        <p:txBody>
+          <a:bodyPr wrap="square" anchor="t" lIns="0" rIns="0" tIns="0" bIns="0">
+            <a:spAutoFit/>
+          </a:bodyPr>
+          <a:lstStyle/>
+          <a:p>
+            <a:pPr algn="l"/>
+            <a:r>
+              <a:rPr sz="1000" b="0" spc="150">
+                <a:solidFill>
+                  <a:srgbClr val="A09D96"/>
+                </a:solidFill>
+                <a:latin typeface="맑은 고딕"/>
+                <a:ea typeface="맑은 고딕"/>
+              </a:rPr>
+              <a:t>AI SEARCH PARADIGM</a:t>
+            </a:r>
+          </a:p>
+        </p:txBody>
+      </p:sp>
+      <p:sp>
+        <p:nvSpPr>
+          <p:cNvPr id="12" name="TextBox 11"/>
+          <p:cNvSpPr txBox="1"/>
+          <p:nvPr/>
+        </p:nvSpPr>
+        <p:spPr>
+          <a:xfrm>
+            <a:off x="932688" y="3474720"/>
+            <a:ext cx="2993136" cy="274320"/>
+          </a:xfrm>
+          <a:prstGeom prst="rect">
+            <a:avLst/>
+          </a:prstGeom>
+          <a:noFill/>
+        </p:spPr>
+        <p:txBody>
+          <a:bodyPr wrap="square" anchor="t" lIns="0" rIns="0" tIns="0" bIns="0">
+            <a:spAutoFit/>
+          </a:bodyPr>
+          <a:lstStyle/>
+          <a:p>
+            <a:pPr algn="l"/>
+            <a:r>
+              <a:rPr sz="1500" b="1">
+                <a:solidFill>
+                  <a:srgbClr val="FAF9F5"/>
+                </a:solidFill>
+                <a:latin typeface="맑은 고딕"/>
+                <a:ea typeface="맑은 고딕"/>
+              </a:rPr>
+              <a:t>AI 검색 패러다임의 전환</a:t>
+            </a:r>
+          </a:p>
+        </p:txBody>
+      </p:sp>
+      <p:sp>
+        <p:nvSpPr>
+          <p:cNvPr id="13" name="TextBox 12"/>
+          <p:cNvSpPr txBox="1"/>
+          <p:nvPr/>
+        </p:nvSpPr>
+        <p:spPr>
+          <a:xfrm>
+            <a:off x="932688" y="3767328"/>
+            <a:ext cx="2993136" cy="457200"/>
+          </a:xfrm>
+          <a:prstGeom prst="rect">
+            <a:avLst/>
+          </a:prstGeom>
+          <a:noFill/>
+        </p:spPr>
+        <p:txBody>
+          <a:bodyPr wrap="square" anchor="t" lIns="0" rIns="0" tIns="0" bIns="0">
+            <a:spAutoFit/>
+          </a:bodyPr>
+          <a:lstStyle/>
+          <a:p>
+            <a:pPr algn="l">
+              <a:lnSpc>
+                <a:spcPct val="120000"/>
+              </a:lnSpc>
+            </a:pPr>
+            <a:r>
+              <a:rPr sz="1050" b="0">
+                <a:solidFill>
+                  <a:srgbClr val="A09D96"/>
+                </a:solidFill>
+                <a:latin typeface="맑은 고딕"/>
+                <a:ea typeface="맑은 고딕"/>
+              </a:rPr>
+              <a:t>검색의 역사와 SEO·AEO·GEO 3단계 모델, AI 검색의 현재 위치</a:t>
+            </a:r>
+          </a:p>
+        </p:txBody>
+      </p:sp>
+      <p:sp>
+        <p:nvSpPr>
+          <p:cNvPr id="14" name="Rounded Rectangle 13"/>
+          <p:cNvSpPr/>
+          <p:nvPr/>
+        </p:nvSpPr>
+        <p:spPr>
+          <a:xfrm>
+            <a:off x="4355592" y="2286000"/>
+            <a:ext cx="3496056" cy="1856232"/>
+          </a:xfrm>
+          <a:prstGeom prst="roundRect">
+            <a:avLst>
+              <a:gd name="adj" fmla="val 6000"/>
+            </a:avLst>
+          </a:prstGeom>
+          <a:solidFill>
+            <a:srgbClr val="EFE9DE"/>
+          </a:solidFill>
+          <a:ln w="12700">
+            <a:solidFill>
+              <a:srgbClr val="E6DFD8"/>
+            </a:solidFill>
+          </a:ln>
+          <a:effectLst/>
+        </p:spPr>
+        <p:style>
+          <a:lnRef idx="1">
+            <a:schemeClr val="accent1"/>
+          </a:lnRef>
+          <a:fillRef idx="3">
+            <a:schemeClr val="accent1"/>
+          </a:fillRef>
+          <a:effectRef idx="2">
+            <a:schemeClr val="accent1"/>
+          </a:effectRef>
+          <a:fontRef idx="minor">
+            <a:schemeClr val="lt1"/>
+          </a:fontRef>
+        </p:style>
+        <p:txBody>
+          <a:bodyPr rtlCol="0" anchor="ctr"/>
+          <a:lstStyle/>
+          <a:p>
+            <a:pPr algn="ctr"/>
+          </a:p>
+        </p:txBody>
+      </p:sp>
+      <p:sp>
+        <p:nvSpPr>
+          <p:cNvPr id="15" name="Rounded Rectangle 14"/>
+          <p:cNvSpPr/>
+          <p:nvPr/>
+        </p:nvSpPr>
+        <p:spPr>
+          <a:xfrm>
+            <a:off x="4629912" y="2560320"/>
+            <a:ext cx="237744" cy="41148"/>
+          </a:xfrm>
+          <a:prstGeom prst="roundRect">
+            <a:avLst>
+              <a:gd name="adj" fmla="val 50000"/>
+            </a:avLst>
+          </a:prstGeom>
+          <a:solidFill>
+            <a:srgbClr val="F37021"/>
+          </a:solidFill>
+          <a:ln>
+            <a:noFill/>
+          </a:ln>
+          <a:effectLst/>
+        </p:spPr>
+        <p:style>
+          <a:lnRef idx="1">
+            <a:schemeClr val="accent1"/>
+          </a:lnRef>
+          <a:fillRef idx="3">
+            <a:schemeClr val="accent1"/>
+          </a:fillRef>
+          <a:effectRef idx="2">
+            <a:schemeClr val="accent1"/>
+          </a:effectRef>
+          <a:fontRef idx="minor">
+            <a:schemeClr val="lt1"/>
+          </a:fontRef>
+        </p:style>
+        <p:txBody>
+          <a:bodyPr rtlCol="0" anchor="ctr"/>
+          <a:lstStyle/>
+          <a:p>
+            <a:pPr algn="ctr"/>
+          </a:p>
+        </p:txBody>
+      </p:sp>
+      <p:sp>
+        <p:nvSpPr>
+          <p:cNvPr id="16" name="TextBox 15"/>
+          <p:cNvSpPr txBox="1"/>
+          <p:nvPr/>
+        </p:nvSpPr>
+        <p:spPr>
+          <a:xfrm>
+            <a:off x="4611624" y="2651760"/>
+            <a:ext cx="3038856" cy="502920"/>
+          </a:xfrm>
+          <a:prstGeom prst="rect">
+            <a:avLst/>
+          </a:prstGeom>
+          <a:noFill/>
+        </p:spPr>
+        <p:txBody>
+          <a:bodyPr wrap="square" anchor="t" lIns="0" rIns="0" tIns="0" bIns="0">
+            <a:spAutoFit/>
+          </a:bodyPr>
+          <a:lstStyle/>
+          <a:p>
+            <a:pPr algn="l"/>
+            <a:r>
+              <a:rPr sz="3200" b="1">
+                <a:solidFill>
+                  <a:srgbClr val="141413"/>
+                </a:solidFill>
+                <a:latin typeface="맑은 고딕"/>
+                <a:ea typeface="맑은 고딕"/>
+              </a:rPr>
+              <a:t>02</a:t>
+            </a:r>
+          </a:p>
+        </p:txBody>
+      </p:sp>
+      <p:sp>
+        <p:nvSpPr>
+          <p:cNvPr id="17" name="TextBox 16"/>
+          <p:cNvSpPr txBox="1"/>
+          <p:nvPr/>
+        </p:nvSpPr>
+        <p:spPr>
+          <a:xfrm>
+            <a:off x="4629912" y="3255264"/>
+            <a:ext cx="2993136" cy="256032"/>
+          </a:xfrm>
+          <a:prstGeom prst="rect">
+            <a:avLst/>
+          </a:prstGeom>
+          <a:noFill/>
+        </p:spPr>
+        <p:txBody>
+          <a:bodyPr wrap="square" anchor="t" lIns="0" rIns="0" tIns="0" bIns="0">
+            <a:spAutoFit/>
+          </a:bodyPr>
+          <a:lstStyle/>
+          <a:p>
+            <a:pPr algn="l"/>
+            <a:r>
+              <a:rPr sz="1000" b="0" spc="150">
+                <a:solidFill>
+                  <a:srgbClr val="6C6A64"/>
+                </a:solidFill>
+                <a:latin typeface="맑은 고딕"/>
+                <a:ea typeface="맑은 고딕"/>
+              </a:rPr>
+              <a:t>FOUNDATION &amp; BUILD</a:t>
+            </a:r>
+          </a:p>
+        </p:txBody>
+      </p:sp>
+      <p:sp>
+        <p:nvSpPr>
+          <p:cNvPr id="18" name="TextBox 17"/>
+          <p:cNvSpPr txBox="1"/>
+          <p:nvPr/>
+        </p:nvSpPr>
+        <p:spPr>
+          <a:xfrm>
+            <a:off x="4629912" y="3474720"/>
+            <a:ext cx="2993136" cy="274320"/>
+          </a:xfrm>
+          <a:prstGeom prst="rect">
+            <a:avLst/>
+          </a:prstGeom>
+          <a:noFill/>
+        </p:spPr>
+        <p:txBody>
+          <a:bodyPr wrap="square" anchor="t" lIns="0" rIns="0" tIns="0" bIns="0">
+            <a:spAutoFit/>
+          </a:bodyPr>
+          <a:lstStyle/>
+          <a:p>
+            <a:pPr algn="l"/>
+            <a:r>
+              <a:rPr sz="1500" b="1">
+                <a:solidFill>
+                  <a:srgbClr val="141413"/>
+                </a:solidFill>
+                <a:latin typeface="맑은 고딕"/>
+                <a:ea typeface="맑은 고딕"/>
+              </a:rPr>
+              <a:t>기초 인프라 셋팅 &amp; 구축</a:t>
+            </a:r>
+          </a:p>
+        </p:txBody>
+      </p:sp>
+      <p:sp>
+        <p:nvSpPr>
+          <p:cNvPr id="19" name="TextBox 18"/>
+          <p:cNvSpPr txBox="1"/>
+          <p:nvPr/>
+        </p:nvSpPr>
+        <p:spPr>
+          <a:xfrm>
+            <a:off x="4629912" y="3767328"/>
+            <a:ext cx="2993136" cy="457200"/>
+          </a:xfrm>
+          <a:prstGeom prst="rect">
+            <a:avLst/>
+          </a:prstGeom>
+          <a:noFill/>
+        </p:spPr>
+        <p:txBody>
+          <a:bodyPr wrap="square" anchor="t" lIns="0" rIns="0" tIns="0" bIns="0">
+            <a:spAutoFit/>
+          </a:bodyPr>
+          <a:lstStyle/>
+          <a:p>
+            <a:pPr algn="l">
+              <a:lnSpc>
+                <a:spcPct val="120000"/>
+              </a:lnSpc>
+            </a:pPr>
+            <a:r>
+              <a:rPr sz="1050" b="0">
+                <a:solidFill>
+                  <a:srgbClr val="3D3D3A"/>
+                </a:solidFill>
+                <a:latin typeface="맑은 고딕"/>
+                <a:ea typeface="맑은 고딕"/>
+              </a:rPr>
+              <a:t>도메인·호스팅·CMS부터 검색엔진 등록까지 사이트 기초</a:t>
+            </a:r>
+          </a:p>
+        </p:txBody>
+      </p:sp>
+      <p:sp>
+        <p:nvSpPr>
+          <p:cNvPr id="20" name="Rounded Rectangle 19"/>
+          <p:cNvSpPr/>
+          <p:nvPr/>
+        </p:nvSpPr>
+        <p:spPr>
+          <a:xfrm>
+            <a:off x="8052816" y="2286000"/>
+            <a:ext cx="3496056" cy="1856232"/>
+          </a:xfrm>
+          <a:prstGeom prst="roundRect">
+            <a:avLst>
+              <a:gd name="adj" fmla="val 6000"/>
+            </a:avLst>
+          </a:prstGeom>
+          <a:solidFill>
+            <a:srgbClr val="EFE9DE"/>
+          </a:solidFill>
+          <a:ln w="12700">
+            <a:solidFill>
+              <a:srgbClr val="E6DFD8"/>
+            </a:solidFill>
+          </a:ln>
+          <a:effectLst/>
+        </p:spPr>
+        <p:style>
+          <a:lnRef idx="1">
+            <a:schemeClr val="accent1"/>
+          </a:lnRef>
+          <a:fillRef idx="3">
+            <a:schemeClr val="accent1"/>
+          </a:fillRef>
+          <a:effectRef idx="2">
+            <a:schemeClr val="accent1"/>
+          </a:effectRef>
+          <a:fontRef idx="minor">
+            <a:schemeClr val="lt1"/>
+          </a:fontRef>
+        </p:style>
+        <p:txBody>
+          <a:bodyPr rtlCol="0" anchor="ctr"/>
+          <a:lstStyle/>
+          <a:p>
+            <a:pPr algn="ctr"/>
+          </a:p>
+        </p:txBody>
+      </p:sp>
+      <p:sp>
+        <p:nvSpPr>
+          <p:cNvPr id="21" name="Rounded Rectangle 20"/>
+          <p:cNvSpPr/>
+          <p:nvPr/>
+        </p:nvSpPr>
+        <p:spPr>
+          <a:xfrm>
+            <a:off x="8327136" y="2560320"/>
+            <a:ext cx="237744" cy="41148"/>
+          </a:xfrm>
+          <a:prstGeom prst="roundRect">
+            <a:avLst>
+              <a:gd name="adj" fmla="val 50000"/>
+            </a:avLst>
+          </a:prstGeom>
+          <a:solidFill>
+            <a:srgbClr val="F37021"/>
+          </a:solidFill>
+          <a:ln>
+            <a:noFill/>
+          </a:ln>
+          <a:effectLst/>
+        </p:spPr>
+        <p:style>
+          <a:lnRef idx="1">
+            <a:schemeClr val="accent1"/>
+          </a:lnRef>
+          <a:fillRef idx="3">
+            <a:schemeClr val="accent1"/>
+          </a:fillRef>
+          <a:effectRef idx="2">
+            <a:schemeClr val="accent1"/>
+          </a:effectRef>
+          <a:fontRef idx="minor">
+            <a:schemeClr val="lt1"/>
+          </a:fontRef>
+        </p:style>
+        <p:txBody>
+          <a:bodyPr rtlCol="0" anchor="ctr"/>
+          <a:lstStyle/>
+          <a:p>
+            <a:pPr algn="ctr"/>
+          </a:p>
+        </p:txBody>
+      </p:sp>
+      <p:sp>
+        <p:nvSpPr>
+          <p:cNvPr id="22" name="TextBox 21"/>
+          <p:cNvSpPr txBox="1"/>
+          <p:nvPr/>
+        </p:nvSpPr>
+        <p:spPr>
+          <a:xfrm>
+            <a:off x="8308848" y="2651760"/>
+            <a:ext cx="3038856" cy="502920"/>
+          </a:xfrm>
+          <a:prstGeom prst="rect">
+            <a:avLst/>
+          </a:prstGeom>
+          <a:noFill/>
+        </p:spPr>
+        <p:txBody>
+          <a:bodyPr wrap="square" anchor="t" lIns="0" rIns="0" tIns="0" bIns="0">
+            <a:spAutoFit/>
+          </a:bodyPr>
+          <a:lstStyle/>
+          <a:p>
+            <a:pPr algn="l"/>
+            <a:r>
+              <a:rPr sz="3200" b="1">
+                <a:solidFill>
+                  <a:srgbClr val="141413"/>
+                </a:solidFill>
+                <a:latin typeface="맑은 고딕"/>
+                <a:ea typeface="맑은 고딕"/>
+              </a:rPr>
+              <a:t>03</a:t>
+            </a:r>
+          </a:p>
+        </p:txBody>
+      </p:sp>
+      <p:sp>
+        <p:nvSpPr>
+          <p:cNvPr id="23" name="TextBox 22"/>
+          <p:cNvSpPr txBox="1"/>
+          <p:nvPr/>
+        </p:nvSpPr>
+        <p:spPr>
+          <a:xfrm>
+            <a:off x="8327136" y="3255264"/>
+            <a:ext cx="2993136" cy="256032"/>
+          </a:xfrm>
+          <a:prstGeom prst="rect">
+            <a:avLst/>
+          </a:prstGeom>
+          <a:noFill/>
+        </p:spPr>
+        <p:txBody>
+          <a:bodyPr wrap="square" anchor="t" lIns="0" rIns="0" tIns="0" bIns="0">
+            <a:spAutoFit/>
+          </a:bodyPr>
+          <a:lstStyle/>
+          <a:p>
+            <a:pPr algn="l"/>
+            <a:r>
+              <a:rPr sz="1000" b="0" spc="150">
+                <a:solidFill>
+                  <a:srgbClr val="6C6A64"/>
+                </a:solidFill>
+                <a:latin typeface="맑은 고딕"/>
+                <a:ea typeface="맑은 고딕"/>
+              </a:rPr>
+              <a:t>TECHNICAL SEO</a:t>
+            </a:r>
+          </a:p>
+        </p:txBody>
+      </p:sp>
+      <p:sp>
+        <p:nvSpPr>
+          <p:cNvPr id="24" name="TextBox 23"/>
+          <p:cNvSpPr txBox="1"/>
+          <p:nvPr/>
+        </p:nvSpPr>
+        <p:spPr>
+          <a:xfrm>
+            <a:off x="8327136" y="3474720"/>
+            <a:ext cx="2993136" cy="274320"/>
+          </a:xfrm>
+          <a:prstGeom prst="rect">
+            <a:avLst/>
+          </a:prstGeom>
+          <a:noFill/>
+        </p:spPr>
+        <p:txBody>
+          <a:bodyPr wrap="square" anchor="t" lIns="0" rIns="0" tIns="0" bIns="0">
+            <a:spAutoFit/>
+          </a:bodyPr>
+          <a:lstStyle/>
+          <a:p>
+            <a:pPr algn="l"/>
+            <a:r>
+              <a:rPr sz="1500" b="1">
+                <a:solidFill>
+                  <a:srgbClr val="141413"/>
+                </a:solidFill>
+                <a:latin typeface="맑은 고딕"/>
+                <a:ea typeface="맑은 고딕"/>
+              </a:rPr>
+              <a:t>테크니컬 SEO 완전정복</a:t>
+            </a:r>
+          </a:p>
+        </p:txBody>
+      </p:sp>
+      <p:sp>
+        <p:nvSpPr>
+          <p:cNvPr id="25" name="TextBox 24"/>
+          <p:cNvSpPr txBox="1"/>
+          <p:nvPr/>
+        </p:nvSpPr>
+        <p:spPr>
+          <a:xfrm>
+            <a:off x="8327136" y="3767328"/>
+            <a:ext cx="2993136" cy="457200"/>
+          </a:xfrm>
+          <a:prstGeom prst="rect">
+            <a:avLst/>
+          </a:prstGeom>
+          <a:noFill/>
+        </p:spPr>
+        <p:txBody>
+          <a:bodyPr wrap="square" anchor="t" lIns="0" rIns="0" tIns="0" bIns="0">
+            <a:spAutoFit/>
+          </a:bodyPr>
+          <a:lstStyle/>
+          <a:p>
+            <a:pPr algn="l">
+              <a:lnSpc>
+                <a:spcPct val="120000"/>
+              </a:lnSpc>
+            </a:pPr>
+            <a:r>
+              <a:rPr sz="1050" b="0">
+                <a:solidFill>
+                  <a:srgbClr val="3D3D3A"/>
+                </a:solidFill>
+                <a:latin typeface="맑은 고딕"/>
+                <a:ea typeface="맑은 고딕"/>
+              </a:rPr>
+              <a:t>크롤링·색인·Core Web Vitals·구조화 데이터·보안</a:t>
+            </a:r>
+          </a:p>
+        </p:txBody>
+      </p:sp>
+      <p:sp>
+        <p:nvSpPr>
+          <p:cNvPr id="26" name="Rounded Rectangle 25"/>
+          <p:cNvSpPr/>
+          <p:nvPr/>
+        </p:nvSpPr>
+        <p:spPr>
+          <a:xfrm>
+            <a:off x="658368" y="4343400"/>
+            <a:ext cx="3496056" cy="1856232"/>
+          </a:xfrm>
+          <a:prstGeom prst="roundRect">
+            <a:avLst>
+              <a:gd name="adj" fmla="val 6000"/>
+            </a:avLst>
+          </a:prstGeom>
+          <a:solidFill>
+            <a:srgbClr val="EFE9DE"/>
+          </a:solidFill>
+          <a:ln w="12700">
+            <a:solidFill>
+              <a:srgbClr val="E6DFD8"/>
+            </a:solidFill>
+          </a:ln>
+          <a:effectLst/>
+        </p:spPr>
+        <p:style>
+          <a:lnRef idx="1">
+            <a:schemeClr val="accent1"/>
+          </a:lnRef>
+          <a:fillRef idx="3">
+            <a:schemeClr val="accent1"/>
+          </a:fillRef>
+          <a:effectRef idx="2">
+            <a:schemeClr val="accent1"/>
+          </a:effectRef>
+          <a:fontRef idx="minor">
+            <a:schemeClr val="lt1"/>
+          </a:fontRef>
+        </p:style>
+        <p:txBody>
+          <a:bodyPr rtlCol="0" anchor="ctr"/>
+          <a:lstStyle/>
+          <a:p>
+            <a:pPr algn="ctr"/>
+          </a:p>
+        </p:txBody>
+      </p:sp>
+      <p:sp>
+        <p:nvSpPr>
+          <p:cNvPr id="27" name="Rounded Rectangle 26"/>
+          <p:cNvSpPr/>
+          <p:nvPr/>
+        </p:nvSpPr>
+        <p:spPr>
+          <a:xfrm>
+            <a:off x="932688" y="4617720"/>
+            <a:ext cx="237744" cy="41148"/>
+          </a:xfrm>
+          <a:prstGeom prst="roundRect">
+            <a:avLst>
+              <a:gd name="adj" fmla="val 50000"/>
+            </a:avLst>
+          </a:prstGeom>
+          <a:solidFill>
+            <a:srgbClr val="F37021"/>
+          </a:solidFill>
+          <a:ln>
+            <a:noFill/>
+          </a:ln>
+          <a:effectLst/>
+        </p:spPr>
+        <p:style>
+          <a:lnRef idx="1">
+            <a:schemeClr val="accent1"/>
+          </a:lnRef>
+          <a:fillRef idx="3">
+            <a:schemeClr val="accent1"/>
+          </a:fillRef>
+          <a:effectRef idx="2">
+            <a:schemeClr val="accent1"/>
+          </a:effectRef>
+          <a:fontRef idx="minor">
+            <a:schemeClr val="lt1"/>
+          </a:fontRef>
+        </p:style>
+        <p:txBody>
+          <a:bodyPr rtlCol="0" anchor="ctr"/>
+          <a:lstStyle/>
+          <a:p>
+            <a:pPr algn="ctr"/>
+          </a:p>
+        </p:txBody>
+      </p:sp>
+      <p:sp>
+        <p:nvSpPr>
+          <p:cNvPr id="28" name="TextBox 27"/>
+          <p:cNvSpPr txBox="1"/>
+          <p:nvPr/>
+        </p:nvSpPr>
+        <p:spPr>
+          <a:xfrm>
+            <a:off x="914400" y="4709160"/>
+            <a:ext cx="3038856" cy="502920"/>
+          </a:xfrm>
+          <a:prstGeom prst="rect">
+            <a:avLst/>
+          </a:prstGeom>
+          <a:noFill/>
+        </p:spPr>
+        <p:txBody>
+          <a:bodyPr wrap="square" anchor="t" lIns="0" rIns="0" tIns="0" bIns="0">
+            <a:spAutoFit/>
+          </a:bodyPr>
+          <a:lstStyle/>
+          <a:p>
+            <a:pPr algn="l"/>
+            <a:r>
+              <a:rPr sz="3200" b="1">
+                <a:solidFill>
+                  <a:srgbClr val="141413"/>
+                </a:solidFill>
+                <a:latin typeface="맑은 고딕"/>
+                <a:ea typeface="맑은 고딕"/>
+              </a:rPr>
+              <a:t>04</a:t>
+            </a:r>
+          </a:p>
+        </p:txBody>
+      </p:sp>
+      <p:sp>
+        <p:nvSpPr>
+          <p:cNvPr id="29" name="TextBox 28"/>
+          <p:cNvSpPr txBox="1"/>
+          <p:nvPr/>
+        </p:nvSpPr>
+        <p:spPr>
+          <a:xfrm>
+            <a:off x="932688" y="5312664"/>
+            <a:ext cx="2993136" cy="256032"/>
+          </a:xfrm>
+          <a:prstGeom prst="rect">
+            <a:avLst/>
+          </a:prstGeom>
+          <a:noFill/>
+        </p:spPr>
+        <p:txBody>
+          <a:bodyPr wrap="square" anchor="t" lIns="0" rIns="0" tIns="0" bIns="0">
+            <a:spAutoFit/>
+          </a:bodyPr>
+          <a:lstStyle/>
+          <a:p>
+            <a:pPr algn="l"/>
+            <a:r>
+              <a:rPr sz="1000" b="0" spc="150">
+                <a:solidFill>
+                  <a:srgbClr val="6C6A64"/>
+                </a:solidFill>
+                <a:latin typeface="맑은 고딕"/>
+                <a:ea typeface="맑은 고딕"/>
+              </a:rPr>
+              <a:t>CONTENT SEO &amp; AEO</a:t>
+            </a:r>
+          </a:p>
+        </p:txBody>
+      </p:sp>
+      <p:sp>
+        <p:nvSpPr>
+          <p:cNvPr id="30" name="TextBox 29"/>
+          <p:cNvSpPr txBox="1"/>
+          <p:nvPr/>
+        </p:nvSpPr>
+        <p:spPr>
+          <a:xfrm>
+            <a:off x="932688" y="5532120"/>
+            <a:ext cx="2993136" cy="274320"/>
+          </a:xfrm>
+          <a:prstGeom prst="rect">
+            <a:avLst/>
+          </a:prstGeom>
+          <a:noFill/>
+        </p:spPr>
+        <p:txBody>
+          <a:bodyPr wrap="square" anchor="t" lIns="0" rIns="0" tIns="0" bIns="0">
+            <a:spAutoFit/>
+          </a:bodyPr>
+          <a:lstStyle/>
+          <a:p>
+            <a:pPr algn="l"/>
+            <a:r>
+              <a:rPr sz="1500" b="1">
+                <a:solidFill>
+                  <a:srgbClr val="141413"/>
+                </a:solidFill>
+                <a:latin typeface="맑은 고딕"/>
+                <a:ea typeface="맑은 고딕"/>
+              </a:rPr>
+              <a:t>콘텐츠 SEO &amp; AEO 실전</a:t>
+            </a:r>
+          </a:p>
+        </p:txBody>
+      </p:sp>
+      <p:sp>
+        <p:nvSpPr>
+          <p:cNvPr id="31" name="TextBox 30"/>
+          <p:cNvSpPr txBox="1"/>
+          <p:nvPr/>
+        </p:nvSpPr>
+        <p:spPr>
+          <a:xfrm>
+            <a:off x="932688" y="5824728"/>
+            <a:ext cx="2993136" cy="457200"/>
+          </a:xfrm>
+          <a:prstGeom prst="rect">
+            <a:avLst/>
+          </a:prstGeom>
+          <a:noFill/>
+        </p:spPr>
+        <p:txBody>
+          <a:bodyPr wrap="square" anchor="t" lIns="0" rIns="0" tIns="0" bIns="0">
+            <a:spAutoFit/>
+          </a:bodyPr>
+          <a:lstStyle/>
+          <a:p>
+            <a:pPr algn="l">
+              <a:lnSpc>
+                <a:spcPct val="120000"/>
+              </a:lnSpc>
+            </a:pPr>
+            <a:r>
+              <a:rPr sz="1050" b="0">
+                <a:solidFill>
+                  <a:srgbClr val="3D3D3A"/>
+                </a:solidFill>
+                <a:latin typeface="맑은 고딕"/>
+                <a:ea typeface="맑은 고딕"/>
+              </a:rPr>
+              <a:t>검색 의도·토픽 클러스터·AEO/GEO 콘텐츠 작성 전략</a:t>
+            </a:r>
+          </a:p>
+        </p:txBody>
+      </p:sp>
+      <p:sp>
+        <p:nvSpPr>
+          <p:cNvPr id="32" name="Rounded Rectangle 31"/>
+          <p:cNvSpPr/>
+          <p:nvPr/>
+        </p:nvSpPr>
+        <p:spPr>
+          <a:xfrm>
+            <a:off x="4355592" y="4343400"/>
+            <a:ext cx="3496056" cy="1856232"/>
+          </a:xfrm>
+          <a:prstGeom prst="roundRect">
+            <a:avLst>
+              <a:gd name="adj" fmla="val 6000"/>
+            </a:avLst>
+          </a:prstGeom>
+          <a:solidFill>
+            <a:srgbClr val="EFE9DE"/>
+          </a:solidFill>
+          <a:ln w="12700">
+            <a:solidFill>
+              <a:srgbClr val="E6DFD8"/>
+            </a:solidFill>
+          </a:ln>
+          <a:effectLst/>
+        </p:spPr>
+        <p:style>
+          <a:lnRef idx="1">
+            <a:schemeClr val="accent1"/>
+          </a:lnRef>
+          <a:fillRef idx="3">
+            <a:schemeClr val="accent1"/>
+          </a:fillRef>
+          <a:effectRef idx="2">
+            <a:schemeClr val="accent1"/>
+          </a:effectRef>
+          <a:fontRef idx="minor">
+            <a:schemeClr val="lt1"/>
+          </a:fontRef>
+        </p:style>
+        <p:txBody>
+          <a:bodyPr rtlCol="0" anchor="ctr"/>
+          <a:lstStyle/>
+          <a:p>
+            <a:pPr algn="ctr"/>
+          </a:p>
+        </p:txBody>
+      </p:sp>
+      <p:sp>
+        <p:nvSpPr>
+          <p:cNvPr id="33" name="Rounded Rectangle 32"/>
+          <p:cNvSpPr/>
+          <p:nvPr/>
+        </p:nvSpPr>
+        <p:spPr>
+          <a:xfrm>
+            <a:off x="4629912" y="4617720"/>
+            <a:ext cx="237744" cy="41148"/>
+          </a:xfrm>
+          <a:prstGeom prst="roundRect">
+            <a:avLst>
+              <a:gd name="adj" fmla="val 50000"/>
+            </a:avLst>
+          </a:prstGeom>
+          <a:solidFill>
+            <a:srgbClr val="F37021"/>
+          </a:solidFill>
+          <a:ln>
+            <a:noFill/>
+          </a:ln>
+          <a:effectLst/>
+        </p:spPr>
+        <p:style>
+          <a:lnRef idx="1">
+            <a:schemeClr val="accent1"/>
+          </a:lnRef>
+          <a:fillRef idx="3">
+            <a:schemeClr val="accent1"/>
+          </a:fillRef>
+          <a:effectRef idx="2">
+            <a:schemeClr val="accent1"/>
+          </a:effectRef>
+          <a:fontRef idx="minor">
+            <a:schemeClr val="lt1"/>
+          </a:fontRef>
+        </p:style>
+        <p:txBody>
+          <a:bodyPr rtlCol="0" anchor="ctr"/>
+          <a:lstStyle/>
+          <a:p>
+            <a:pPr algn="ctr"/>
+          </a:p>
+        </p:txBody>
+      </p:sp>
+      <p:sp>
+        <p:nvSpPr>
+          <p:cNvPr id="34" name="TextBox 33"/>
+          <p:cNvSpPr txBox="1"/>
+          <p:nvPr/>
+        </p:nvSpPr>
+        <p:spPr>
+          <a:xfrm>
+            <a:off x="4611624" y="4709160"/>
+            <a:ext cx="3038856" cy="502920"/>
+          </a:xfrm>
+          <a:prstGeom prst="rect">
+            <a:avLst/>
+          </a:prstGeom>
+          <a:noFill/>
+        </p:spPr>
+        <p:txBody>
+          <a:bodyPr wrap="square" anchor="t" lIns="0" rIns="0" tIns="0" bIns="0">
+            <a:spAutoFit/>
+          </a:bodyPr>
+          <a:lstStyle/>
+          <a:p>
+            <a:pPr algn="l"/>
+            <a:r>
+              <a:rPr sz="3200" b="1">
+                <a:solidFill>
+                  <a:srgbClr val="141413"/>
+                </a:solidFill>
+                <a:latin typeface="맑은 고딕"/>
+                <a:ea typeface="맑은 고딕"/>
+              </a:rPr>
+              <a:t>05</a:t>
+            </a:r>
+          </a:p>
+        </p:txBody>
+      </p:sp>
+      <p:sp>
+        <p:nvSpPr>
+          <p:cNvPr id="35" name="TextBox 34"/>
+          <p:cNvSpPr txBox="1"/>
+          <p:nvPr/>
+        </p:nvSpPr>
+        <p:spPr>
+          <a:xfrm>
+            <a:off x="4629912" y="5312664"/>
+            <a:ext cx="2993136" cy="256032"/>
+          </a:xfrm>
+          <a:prstGeom prst="rect">
+            <a:avLst/>
+          </a:prstGeom>
+          <a:noFill/>
+        </p:spPr>
+        <p:txBody>
+          <a:bodyPr wrap="square" anchor="t" lIns="0" rIns="0" tIns="0" bIns="0">
+            <a:spAutoFit/>
+          </a:bodyPr>
+          <a:lstStyle/>
+          <a:p>
+            <a:pPr algn="l"/>
+            <a:r>
+              <a:rPr sz="1000" b="0" spc="150">
+                <a:solidFill>
+                  <a:srgbClr val="6C6A64"/>
+                </a:solidFill>
+                <a:latin typeface="맑은 고딕"/>
+                <a:ea typeface="맑은 고딕"/>
+              </a:rPr>
+              <a:t>LINK BUILDING &amp; GEO</a:t>
+            </a:r>
+          </a:p>
+        </p:txBody>
+      </p:sp>
+      <p:sp>
+        <p:nvSpPr>
+          <p:cNvPr id="36" name="TextBox 35"/>
+          <p:cNvSpPr txBox="1"/>
+          <p:nvPr/>
+        </p:nvSpPr>
+        <p:spPr>
+          <a:xfrm>
+            <a:off x="4629912" y="5532120"/>
+            <a:ext cx="2993136" cy="274320"/>
+          </a:xfrm>
+          <a:prstGeom prst="rect">
+            <a:avLst/>
+          </a:prstGeom>
+          <a:noFill/>
+        </p:spPr>
+        <p:txBody>
+          <a:bodyPr wrap="square" anchor="t" lIns="0" rIns="0" tIns="0" bIns="0">
+            <a:spAutoFit/>
+          </a:bodyPr>
+          <a:lstStyle/>
+          <a:p>
+            <a:pPr algn="l"/>
+            <a:r>
+              <a:rPr sz="1500" b="1">
+                <a:solidFill>
+                  <a:srgbClr val="141413"/>
+                </a:solidFill>
+                <a:latin typeface="맑은 고딕"/>
+                <a:ea typeface="맑은 고딕"/>
+              </a:rPr>
+              <a:t>링크빌딩 SEO &amp; GEO 실전</a:t>
+            </a:r>
+          </a:p>
+        </p:txBody>
+      </p:sp>
+      <p:sp>
+        <p:nvSpPr>
+          <p:cNvPr id="37" name="TextBox 36"/>
+          <p:cNvSpPr txBox="1"/>
+          <p:nvPr/>
+        </p:nvSpPr>
+        <p:spPr>
+          <a:xfrm>
+            <a:off x="4629912" y="5824728"/>
+            <a:ext cx="2993136" cy="457200"/>
+          </a:xfrm>
+          <a:prstGeom prst="rect">
+            <a:avLst/>
+          </a:prstGeom>
+          <a:noFill/>
+        </p:spPr>
+        <p:txBody>
+          <a:bodyPr wrap="square" anchor="t" lIns="0" rIns="0" tIns="0" bIns="0">
+            <a:spAutoFit/>
+          </a:bodyPr>
+          <a:lstStyle/>
+          <a:p>
+            <a:pPr algn="l">
+              <a:lnSpc>
+                <a:spcPct val="120000"/>
+              </a:lnSpc>
+            </a:pPr>
+            <a:r>
+              <a:rPr sz="1050" b="0">
+                <a:solidFill>
+                  <a:srgbClr val="3D3D3A"/>
+                </a:solidFill>
+                <a:latin typeface="맑은 고딕"/>
+                <a:ea typeface="맑은 고딕"/>
+              </a:rPr>
+              <a:t>화이트햇 링크빌딩·Entity SEO·GEO 5대 전략과 KPI</a:t>
+            </a:r>
+          </a:p>
+        </p:txBody>
+      </p:sp>
+      <p:sp>
+        <p:nvSpPr>
+          <p:cNvPr id="38" name="Rounded Rectangle 37"/>
+          <p:cNvSpPr/>
+          <p:nvPr/>
+        </p:nvSpPr>
+        <p:spPr>
+          <a:xfrm>
+            <a:off x="8052816" y="4343400"/>
+            <a:ext cx="3496056" cy="1856232"/>
+          </a:xfrm>
+          <a:prstGeom prst="roundRect">
+            <a:avLst>
+              <a:gd name="adj" fmla="val 6000"/>
+            </a:avLst>
+          </a:prstGeom>
+          <a:solidFill>
+            <a:srgbClr val="EFE9DE"/>
+          </a:solidFill>
+          <a:ln w="12700">
+            <a:solidFill>
+              <a:srgbClr val="E6DFD8"/>
+            </a:solidFill>
+          </a:ln>
+          <a:effectLst/>
+        </p:spPr>
+        <p:style>
+          <a:lnRef idx="1">
+            <a:schemeClr val="accent1"/>
+          </a:lnRef>
+          <a:fillRef idx="3">
+            <a:schemeClr val="accent1"/>
+          </a:fillRef>
+          <a:effectRef idx="2">
+            <a:schemeClr val="accent1"/>
+          </a:effectRef>
+          <a:fontRef idx="minor">
+            <a:schemeClr val="lt1"/>
+          </a:fontRef>
+        </p:style>
+        <p:txBody>
+          <a:bodyPr rtlCol="0" anchor="ctr"/>
+          <a:lstStyle/>
+          <a:p>
+            <a:pPr algn="ctr"/>
+          </a:p>
+        </p:txBody>
+      </p:sp>
+      <p:sp>
+        <p:nvSpPr>
+          <p:cNvPr id="39" name="Rounded Rectangle 38"/>
+          <p:cNvSpPr/>
+          <p:nvPr/>
+        </p:nvSpPr>
+        <p:spPr>
+          <a:xfrm>
+            <a:off x="8327136" y="4617720"/>
+            <a:ext cx="237744" cy="41148"/>
+          </a:xfrm>
+          <a:prstGeom prst="roundRect">
+            <a:avLst>
+              <a:gd name="adj" fmla="val 50000"/>
+            </a:avLst>
+          </a:prstGeom>
+          <a:solidFill>
+            <a:srgbClr val="F37021"/>
+          </a:solidFill>
+          <a:ln>
+            <a:noFill/>
+          </a:ln>
+          <a:effectLst/>
+        </p:spPr>
+        <p:style>
+          <a:lnRef idx="1">
+            <a:schemeClr val="accent1"/>
+          </a:lnRef>
+          <a:fillRef idx="3">
+            <a:schemeClr val="accent1"/>
+          </a:fillRef>
+          <a:effectRef idx="2">
+            <a:schemeClr val="accent1"/>
+          </a:effectRef>
+          <a:fontRef idx="minor">
+            <a:schemeClr val="lt1"/>
+          </a:fontRef>
+        </p:style>
+        <p:txBody>
+          <a:bodyPr rtlCol="0" anchor="ctr"/>
+          <a:lstStyle/>
+          <a:p>
+            <a:pPr algn="ctr"/>
+          </a:p>
+        </p:txBody>
+      </p:sp>
+      <p:sp>
+        <p:nvSpPr>
+          <p:cNvPr id="40" name="TextBox 39"/>
+          <p:cNvSpPr txBox="1"/>
+          <p:nvPr/>
+        </p:nvSpPr>
+        <p:spPr>
+          <a:xfrm>
+            <a:off x="8308848" y="4709160"/>
+            <a:ext cx="3038856" cy="502920"/>
+          </a:xfrm>
+          <a:prstGeom prst="rect">
+            <a:avLst/>
+          </a:prstGeom>
+          <a:noFill/>
+        </p:spPr>
+        <p:txBody>
+          <a:bodyPr wrap="square" anchor="t" lIns="0" rIns="0" tIns="0" bIns="0">
+            <a:spAutoFit/>
+          </a:bodyPr>
+          <a:lstStyle/>
+          <a:p>
+            <a:pPr algn="l"/>
+            <a:r>
+              <a:rPr sz="3200" b="1">
+                <a:solidFill>
+                  <a:srgbClr val="141413"/>
+                </a:solidFill>
+                <a:latin typeface="맑은 고딕"/>
+                <a:ea typeface="맑은 고딕"/>
+              </a:rPr>
+              <a:t>06</a:t>
+            </a:r>
+          </a:p>
+        </p:txBody>
+      </p:sp>
+      <p:sp>
+        <p:nvSpPr>
+          <p:cNvPr id="41" name="TextBox 40"/>
+          <p:cNvSpPr txBox="1"/>
+          <p:nvPr/>
+        </p:nvSpPr>
+        <p:spPr>
+          <a:xfrm>
+            <a:off x="8327136" y="5312664"/>
+            <a:ext cx="2993136" cy="256032"/>
+          </a:xfrm>
+          <a:prstGeom prst="rect">
+            <a:avLst/>
+          </a:prstGeom>
+          <a:noFill/>
+        </p:spPr>
+        <p:txBody>
+          <a:bodyPr wrap="square" anchor="t" lIns="0" rIns="0" tIns="0" bIns="0">
+            <a:spAutoFit/>
+          </a:bodyPr>
+          <a:lstStyle/>
+          <a:p>
+            <a:pPr algn="l"/>
+            <a:r>
+              <a:rPr sz="1000" b="0" spc="150">
+                <a:solidFill>
+                  <a:srgbClr val="6C6A64"/>
+                </a:solidFill>
+                <a:latin typeface="맑은 고딕"/>
+                <a:ea typeface="맑은 고딕"/>
+              </a:rPr>
+              <a:t>INTEGRATION &amp; OUTLOOK</a:t>
+            </a:r>
+          </a:p>
+        </p:txBody>
+      </p:sp>
+      <p:sp>
+        <p:nvSpPr>
+          <p:cNvPr id="42" name="TextBox 41"/>
+          <p:cNvSpPr txBox="1"/>
+          <p:nvPr/>
+        </p:nvSpPr>
+        <p:spPr>
+          <a:xfrm>
+            <a:off x="8327136" y="5532120"/>
+            <a:ext cx="2993136" cy="274320"/>
+          </a:xfrm>
+          <a:prstGeom prst="rect">
+            <a:avLst/>
+          </a:prstGeom>
+          <a:noFill/>
+        </p:spPr>
+        <p:txBody>
+          <a:bodyPr wrap="square" anchor="t" lIns="0" rIns="0" tIns="0" bIns="0">
+            <a:spAutoFit/>
+          </a:bodyPr>
+          <a:lstStyle/>
+          <a:p>
+            <a:pPr algn="l"/>
+            <a:r>
+              <a:rPr sz="1500" b="1">
+                <a:solidFill>
+                  <a:srgbClr val="141413"/>
+                </a:solidFill>
+                <a:latin typeface="맑은 고딕"/>
+                <a:ea typeface="맑은 고딕"/>
+              </a:rPr>
+              <a:t>통합 전략·자동화·전망</a:t>
+            </a:r>
+          </a:p>
+        </p:txBody>
+      </p:sp>
+      <p:sp>
+        <p:nvSpPr>
+          <p:cNvPr id="43" name="TextBox 42"/>
+          <p:cNvSpPr txBox="1"/>
+          <p:nvPr/>
+        </p:nvSpPr>
+        <p:spPr>
+          <a:xfrm>
+            <a:off x="8327136" y="5824728"/>
+            <a:ext cx="2993136" cy="457200"/>
+          </a:xfrm>
+          <a:prstGeom prst="rect">
+            <a:avLst/>
+          </a:prstGeom>
+          <a:noFill/>
+        </p:spPr>
+        <p:txBody>
+          <a:bodyPr wrap="square" anchor="t" lIns="0" rIns="0" tIns="0" bIns="0">
+            <a:spAutoFit/>
+          </a:bodyPr>
+          <a:lstStyle/>
+          <a:p>
+            <a:pPr algn="l">
+              <a:lnSpc>
+                <a:spcPct val="120000"/>
+              </a:lnSpc>
+            </a:pPr>
+            <a:r>
+              <a:rPr sz="1050" b="0">
+                <a:solidFill>
+                  <a:srgbClr val="3D3D3A"/>
+                </a:solidFill>
+                <a:latin typeface="맑은 고딕"/>
+                <a:ea typeface="맑은 고딕"/>
+              </a:rPr>
+              <a:t>상황별 전략·콘텐츠 자동화·2026~2028 시장 전망</a:t>
+            </a:r>
+          </a:p>
+        </p:txBody>
+      </p:sp>
+      <p:sp>
+        <p:nvSpPr>
+          <p:cNvPr id="44" name="Rectangle 43"/>
+          <p:cNvSpPr/>
+          <p:nvPr/>
+        </p:nvSpPr>
+        <p:spPr>
+          <a:xfrm>
+            <a:off x="658368" y="6419088"/>
+            <a:ext cx="10890504" cy="9144"/>
+          </a:xfrm>
+          <a:prstGeom prst="rect">
+            <a:avLst/>
+          </a:prstGeom>
+          <a:solidFill>
+            <a:srgbClr val="E6DFD8"/>
+          </a:solidFill>
+          <a:ln>
+            <a:noFill/>
+          </a:ln>
+          <a:effectLst/>
+        </p:spPr>
+        <p:style>
+          <a:lnRef idx="1">
+            <a:schemeClr val="accent1"/>
+          </a:lnRef>
+          <a:fillRef idx="3">
+            <a:schemeClr val="accent1"/>
+          </a:fillRef>
+          <a:effectRef idx="2">
+            <a:schemeClr val="accent1"/>
+          </a:effectRef>
+          <a:fontRef idx="minor">
+            <a:schemeClr val="lt1"/>
+          </a:fontRef>
+        </p:style>
+        <p:txBody>
+          <a:bodyPr rtlCol="0" anchor="ctr"/>
+          <a:lstStyle/>
+          <a:p>
+            <a:pPr algn="ctr"/>
+          </a:p>
+        </p:txBody>
+      </p:sp>
+      <p:sp>
+        <p:nvSpPr>
+          <p:cNvPr id="45" name="TextBox 44"/>
+          <p:cNvSpPr txBox="1"/>
+          <p:nvPr/>
+        </p:nvSpPr>
+        <p:spPr>
+          <a:xfrm>
+            <a:off x="658368" y="6473952"/>
+            <a:ext cx="6400800" cy="274320"/>
+          </a:xfrm>
+          <a:prstGeom prst="rect">
+            <a:avLst/>
+          </a:prstGeom>
+          <a:noFill/>
+        </p:spPr>
+        <p:txBody>
+          <a:bodyPr wrap="square" anchor="t" lIns="0" rIns="0" tIns="0" bIns="0">
+            <a:spAutoFit/>
+          </a:bodyPr>
+          <a:lstStyle/>
+          <a:p>
+            <a:pPr algn="l"/>
+            <a:r>
+              <a:rPr sz="900" b="0" spc="50">
+                <a:solidFill>
+                  <a:srgbClr val="8E8B82"/>
+                </a:solidFill>
+                <a:latin typeface="맑은 고딕"/>
+                <a:ea typeface="맑은 고딕"/>
+              </a:rPr>
+              <a:t>SEO · AEO · GEO — AI 검색 시대 마케팅</a:t>
+            </a:r>
+          </a:p>
+        </p:txBody>
+      </p:sp>
+      <p:sp>
+        <p:nvSpPr>
+          <p:cNvPr id="46" name="TextBox 45"/>
+          <p:cNvSpPr txBox="1"/>
+          <p:nvPr/>
+        </p:nvSpPr>
+        <p:spPr>
+          <a:xfrm>
+            <a:off x="8229600" y="6473952"/>
+            <a:ext cx="3319272" cy="274320"/>
+          </a:xfrm>
+          <a:prstGeom prst="rect">
+            <a:avLst/>
+          </a:prstGeom>
+          <a:noFill/>
+        </p:spPr>
+        <p:txBody>
+          <a:bodyPr wrap="square" anchor="t" lIns="0" rIns="0" tIns="0" bIns="0">
+            <a:spAutoFit/>
+          </a:bodyPr>
+          <a:lstStyle/>
+          <a:p>
+            <a:pPr algn="r"/>
+            <a:r>
+              <a:rPr sz="900" b="0" spc="120">
+                <a:solidFill>
+                  <a:srgbClr val="8E8B82"/>
+                </a:solidFill>
+                <a:latin typeface="맑은 고딕"/>
+                <a:ea typeface="맑은 고딕"/>
+              </a:rPr>
+              <a:t>COURSE OVERVIEW</a:t>
+            </a:r>
+          </a:p>
         </p:txBody>
       </p:sp>
     </p:spTree>

</xml_diff>